<commit_message>
Fix PPTX XML parse error - escape special characters
Added xml.sax.saxutils.escape() to handle &, <, > characters
in slide text content. The '>' in slide 9 was breaking Keynote/
Notability XML parser. All 14 XML files now validate correctly.
</commit_message>
<xml_diff>
--- a/UKPSC_HC_ARO_2026_Analysis.pptx
+++ b/UKPSC_HC_ARO_2026_Analysis.pptx
@@ -77,106 +77,439 @@
 </p:sldMaster>
 </file>
 
-<file path=ppt/slides/slide1.xml><?xml version="1.0" encoding="UTF-8" standalone="yes"?>
-<p:sld xmlns:a="http://schemas.openxmlformats.org/drawingml/2006/main"
-       xmlns:r="http://schemas.openxmlformats.org/officeDocument/2006/relationships"
-       xmlns:p="http://schemas.openxmlformats.org/presentationml/2006/main">
+<file path=ppt/slides/slide1.xml><?xml version="1.0" encoding="utf-8"?>
+<p:sld xmlns:a="http://schemas.openxmlformats.org/drawingml/2006/main" xmlns:r="http://schemas.openxmlformats.org/officeDocument/2006/relationships" xmlns:p="http://schemas.openxmlformats.org/presentationml/2006/main">
   <p:cSld>
-    <p:bg><p:bgPr><a:solidFill><a:srgbClr val="16233A"/></a:solidFill><a:effectLst/></p:bgPr></p:bg>
+    <p:bg>
+      <p:bgPr>
+        <a:solidFill>
+          <a:srgbClr val="16233A"/>
+        </a:solidFill>
+        <a:effectLst/>
+      </p:bgPr>
+    </p:bg>
     <p:spTree>
-      <p:nvGrpSpPr><p:cNvPr id="1" name=""/><p:cNvGrpSpPr/><p:nvPr/></p:nvGrpSpPr>
+      <p:nvGrpSpPr>
+        <p:cNvPr id="1" name=""/>
+        <p:cNvGrpSpPr/>
+        <p:nvPr/>
+      </p:nvGrpSpPr>
       <p:grpSpPr>
-        <a:xfrm><a:off x="0" y="0"/><a:ext cx="0" cy="0"/><a:chOff x="0" y="0"/><a:chExt cx="0" cy="0"/></a:xfrm>
+        <a:xfrm>
+          <a:off x="0" y="0"/>
+          <a:ext cx="0" cy="0"/>
+          <a:chOff x="0" y="0"/>
+          <a:chExt cx="0" cy="0"/>
+        </a:xfrm>
       </p:grpSpPr>
       <p:sp>
-  <p:nvSpPr><p:cNvPr id="0" name="TB"/><p:cNvSpPr txBox="1"/><p:nvPr/></p:nvSpPr>
-  <p:spPr>
-    <a:xfrm><a:off x="731520" y="731520"/><a:ext cx="10698480" cy="457200"/></a:xfrm>
-    <a:prstGeom prst="rect"><a:avLst/></a:prstGeom><a:noFill/>
-  </p:spPr>
-  <p:txBody><a:bodyPr wrap="square" rtlCol="0"/><a:lstStyle/><a:p><a:pPr algn="l"/><a:r><a:rPr lang="en-US" sz="1500" b="1" dirty="0"><a:solidFill><a:srgbClr val="E0A458"/></a:solidFill><a:latin typeface="Calibri"/></a:rPr><a:t>UKPSC HIGH COURT ARO PRELIMS 2026</a:t></a:r></a:p></p:txBody>
-</p:sp><p:sp>
-  <p:nvSpPr><p:cNvPr id="0" name="TB"/><p:cNvSpPr txBox="1"/><p:nvPr/></p:nvSpPr>
-  <p:spPr>
-    <a:xfrm><a:off x="731520" y="1371600"/><a:ext cx="10698480" cy="1828800"/></a:xfrm>
-    <a:prstGeom prst="rect"><a:avLst/></a:prstGeom><a:noFill/>
-  </p:spPr>
-  <p:txBody><a:bodyPr wrap="square" rtlCol="0"/><a:lstStyle/><a:p><a:pPr algn="l"/><a:r><a:rPr lang="en-US" sz="3800" b="1" dirty="0"><a:solidFill><a:srgbClr val="FFFFFF"/></a:solidFill><a:latin typeface="Calibri"/></a:rPr><a:t>Complete Paper Analysis</a:t></a:r></a:p><a:p><a:pPr algn="l"/><a:r><a:rPr lang="en-US" sz="3200" b="1" dirty="0"><a:solidFill><a:srgbClr val="FFFFFF"/></a:solidFill><a:latin typeface="Calibri"/></a:rPr><a:t>& Expected Cut-Off</a:t></a:r></a:p></p:txBody>
-</p:sp><p:sp>
-  <p:nvSpPr><p:cNvPr id="0" name="TB"/><p:cNvSpPr txBox="1"/><p:nvPr/></p:nvSpPr>
-  <p:spPr>
-    <a:xfrm><a:off x="731520" y="3291840"/><a:ext cx="10058400" cy="457200"/></a:xfrm>
-    <a:prstGeom prst="rect"><a:avLst/></a:prstGeom><a:noFill/>
-  </p:spPr>
-  <p:txBody><a:bodyPr wrap="square" rtlCol="0"/><a:lstStyle/><a:p><a:pPr algn="l"/><a:r><a:rPr lang="en-US" sz="1500" dirty="0"><a:solidFill><a:srgbClr val="C7CFDB"/></a:solidFill><a:latin typeface="Calibri"/></a:rPr><a:t>19 July 2026 | HCA Series-A | 200 Marks | Only 15 Seats</a:t></a:r></a:p></p:txBody>
-</p:sp><p:sp>
-  <p:nvSpPr><p:cNvPr id="0" name="B1"/><p:cNvSpPr/><p:nvPr/></p:nvSpPr>
-  <p:spPr>
-    <a:xfrm><a:off x="731520" y="4389120"/><a:ext cx="3200400" cy="1280160"/></a:xfrm>
-    <a:prstGeom prst="roundRect"><a:avLst><a:gd name="adj" fmla="val 5000"/></a:avLst></a:prstGeom>
-    <a:solidFill><a:srgbClr val="2E4057"/></a:solidFill>
-    <a:ln><a:noFill/></a:ln>
-  </p:spPr>
-  <p:txBody><a:bodyPr/><a:lstStyle/><a:p><a:endParaRPr lang="en-US"/></a:p></p:txBody>
-</p:sp><p:sp>
-  <p:nvSpPr><p:cNvPr id="0" name="TB"/><p:cNvSpPr txBox="1"/><p:nvPr/></p:nvSpPr>
-  <p:spPr>
-    <a:xfrm><a:off x="822960" y="4480560"/><a:ext cx="3017520" cy="1097280"/></a:xfrm>
-    <a:prstGeom prst="rect"><a:avLst/></a:prstGeom><a:noFill/>
-  </p:spPr>
-  <p:txBody><a:bodyPr wrap="square" rtlCol="0"/><a:lstStyle/><a:p><a:pPr algn="ctr"/><a:r><a:rPr lang="en-US" sz="3600" b="1" dirty="0"><a:solidFill><a:srgbClr val="E0A458"/></a:solidFill><a:latin typeface="Calibri"/></a:rPr><a:t>200</a:t></a:r></a:p><a:p><a:pPr algn="ctr"/><a:r><a:rPr lang="en-US" sz="1200" dirty="0"><a:solidFill><a:srgbClr val="C7CFDB"/></a:solidFill><a:latin typeface="Calibri"/></a:rPr><a:t>Total Marks</a:t></a:r></a:p></p:txBody>
-</p:sp><p:sp>
-  <p:nvSpPr><p:cNvPr id="0" name="B2"/><p:cNvSpPr/><p:nvPr/></p:nvSpPr>
-  <p:spPr>
-    <a:xfrm><a:off x="4206240" y="4389120"/><a:ext cx="3200400" cy="1280160"/></a:xfrm>
-    <a:prstGeom prst="roundRect"><a:avLst><a:gd name="adj" fmla="val 5000"/></a:avLst></a:prstGeom>
-    <a:solidFill><a:srgbClr val="2E4057"/></a:solidFill>
-    <a:ln><a:noFill/></a:ln>
-  </p:spPr>
-  <p:txBody><a:bodyPr/><a:lstStyle/><a:p><a:endParaRPr lang="en-US"/></a:p></p:txBody>
-</p:sp><p:sp>
-  <p:nvSpPr><p:cNvPr id="0" name="TB"/><p:cNvSpPr txBox="1"/><p:nvPr/></p:nvSpPr>
-  <p:spPr>
-    <a:xfrm><a:off x="4297680" y="4480560"/><a:ext cx="3017520" cy="1097280"/></a:xfrm>
-    <a:prstGeom prst="rect"><a:avLst/></a:prstGeom><a:noFill/>
-  </p:spPr>
-  <p:txBody><a:bodyPr wrap="square" rtlCol="0"/><a:lstStyle/><a:p><a:pPr algn="ctr"/><a:r><a:rPr lang="en-US" sz="3600" b="1" dirty="0"><a:solidFill><a:srgbClr val="DC3545"/></a:solidFill><a:latin typeface="Calibri"/></a:rPr><a:t>15</a:t></a:r></a:p><a:p><a:pPr algn="ctr"/><a:r><a:rPr lang="en-US" sz="1200" dirty="0"><a:solidFill><a:srgbClr val="C7CFDB"/></a:solidFill><a:latin typeface="Calibri"/></a:rPr><a:t>Seats Only!</a:t></a:r></a:p></p:txBody>
-</p:sp><p:sp>
-  <p:nvSpPr><p:cNvPr id="0" name="B3"/><p:cNvSpPr/><p:nvPr/></p:nvSpPr>
-  <p:spPr>
-    <a:xfrm><a:off x="7680960" y="4389120"/><a:ext cx="3200400" cy="1280160"/></a:xfrm>
-    <a:prstGeom prst="roundRect"><a:avLst><a:gd name="adj" fmla="val 5000"/></a:avLst></a:prstGeom>
-    <a:solidFill><a:srgbClr val="2E4057"/></a:solidFill>
-    <a:ln><a:noFill/></a:ln>
-  </p:spPr>
-  <p:txBody><a:bodyPr/><a:lstStyle/><a:p><a:endParaRPr lang="en-US"/></a:p></p:txBody>
-</p:sp><p:sp>
-  <p:nvSpPr><p:cNvPr id="0" name="TB"/><p:cNvSpPr txBox="1"/><p:nvPr/></p:nvSpPr>
-  <p:spPr>
-    <a:xfrm><a:off x="7772400" y="4480560"/><a:ext cx="3017520" cy="1097280"/></a:xfrm>
-    <a:prstGeom prst="rect"><a:avLst/></a:prstGeom><a:noFill/>
-  </p:spPr>
-  <p:txBody><a:bodyPr wrap="square" rtlCol="0"/><a:lstStyle/><a:p><a:pPr algn="ctr"/><a:r><a:rPr lang="en-US" sz="3200" b="1" dirty="0"><a:solidFill><a:srgbClr val="E0A458"/></a:solidFill><a:latin typeface="Calibri"/></a:rPr><a:t>0.25</a:t></a:r></a:p><a:p><a:pPr algn="ctr"/><a:r><a:rPr lang="en-US" sz="1200" dirty="0"><a:solidFill><a:srgbClr val="C7CFDB"/></a:solidFill><a:latin typeface="Calibri"/></a:rPr><a:t>Negative/Wrong</a:t></a:r></a:p></p:txBody>
-</p:sp><p:sp>
-  <p:nvSpPr><p:cNvPr id="0" name="Warn"/><p:cNvSpPr/><p:nvPr/></p:nvSpPr>
-  <p:spPr>
-    <a:xfrm><a:off x="731520" y="5943600"/><a:ext cx="10698480" cy="548640"/></a:xfrm>
-    <a:prstGeom prst="roundRect"><a:avLst><a:gd name="adj" fmla="val 5000"/></a:avLst></a:prstGeom>
-    <a:solidFill><a:srgbClr val="DC3545"/></a:solidFill>
-    <a:ln><a:noFill/></a:ln>
-  </p:spPr>
-  <p:txBody><a:bodyPr/><a:lstStyle/><a:p><a:endParaRPr lang="en-US"/></a:p></p:txBody>
-</p:sp><p:sp>
-  <p:nvSpPr><p:cNvPr id="0" name="TB"/><p:cNvSpPr txBox="1"/><p:nvPr/></p:nvSpPr>
-  <p:spPr>
-    <a:xfrm><a:off x="914400" y="5989320"/><a:ext cx="10332720" cy="457200"/></a:xfrm>
-    <a:prstGeom prst="rect"><a:avLst/></a:prstGeom><a:noFill/>
-  </p:spPr>
-  <p:txBody><a:bodyPr wrap="square" rtlCol="0"/><a:lstStyle/><a:p><a:pPr algn="ctr"/><a:r><a:rPr lang="en-US" sz="1400" b="1" dirty="0"><a:solidFill><a:srgbClr val="FFFFFF"/></a:solidFill><a:latin typeface="Calibri"/></a:rPr><a:t>EXTREME COMPETITION: 15 Seats = Every Single Mark Counts!</a:t></a:r></a:p></p:txBody>
-</p:sp>
+        <p:nvSpPr>
+          <p:cNvPr id="0" name="TB"/>
+          <p:cNvSpPr txBox="1"/>
+          <p:nvPr/>
+        </p:nvSpPr>
+        <p:spPr>
+          <a:xfrm>
+            <a:off x="731520" y="731520"/>
+            <a:ext cx="10698480" cy="457200"/>
+          </a:xfrm>
+          <a:prstGeom prst="rect">
+            <a:avLst/>
+          </a:prstGeom>
+          <a:noFill/>
+        </p:spPr>
+        <p:txBody>
+          <a:bodyPr wrap="square" rtlCol="0"/>
+          <a:lstStyle/>
+          <a:p>
+            <a:pPr algn="l"/>
+            <a:r>
+              <a:rPr lang="en-US" sz="1500" b="1" dirty="0">
+                <a:solidFill>
+                  <a:srgbClr val="E0A458"/>
+                </a:solidFill>
+                <a:latin typeface="Calibri"/>
+              </a:rPr>
+              <a:t>UKPSC HIGH COURT ARO PRELIMS 2026</a:t>
+            </a:r>
+          </a:p>
+        </p:txBody>
+      </p:sp>
+      <p:sp>
+        <p:nvSpPr>
+          <p:cNvPr id="0" name="TB"/>
+          <p:cNvSpPr txBox="1"/>
+          <p:nvPr/>
+        </p:nvSpPr>
+        <p:spPr>
+          <a:xfrm>
+            <a:off x="731520" y="1371600"/>
+            <a:ext cx="10698480" cy="1828800"/>
+          </a:xfrm>
+          <a:prstGeom prst="rect">
+            <a:avLst/>
+          </a:prstGeom>
+          <a:noFill/>
+        </p:spPr>
+        <p:txBody>
+          <a:bodyPr wrap="square" rtlCol="0"/>
+          <a:lstStyle/>
+          <a:p>
+            <a:pPr algn="l"/>
+            <a:r>
+              <a:rPr lang="en-US" sz="3800" b="1" dirty="0">
+                <a:solidFill>
+                  <a:srgbClr val="FFFFFF"/>
+                </a:solidFill>
+                <a:latin typeface="Calibri"/>
+              </a:rPr>
+              <a:t>Complete Paper Analysis</a:t>
+            </a:r>
+          </a:p>
+          <a:p>
+            <a:pPr algn="l"/>
+            <a:r>
+              <a:rPr lang="en-US" sz="3200" b="1" dirty="0">
+                <a:solidFill>
+                  <a:srgbClr val="FFFFFF"/>
+                </a:solidFill>
+                <a:latin typeface="Calibri"/>
+              </a:rPr>
+              <a:t>&amp; Expected Cut-Off</a:t>
+            </a:r>
+          </a:p>
+        </p:txBody>
+      </p:sp>
+      <p:sp>
+        <p:nvSpPr>
+          <p:cNvPr id="0" name="TB"/>
+          <p:cNvSpPr txBox="1"/>
+          <p:nvPr/>
+        </p:nvSpPr>
+        <p:spPr>
+          <a:xfrm>
+            <a:off x="731520" y="3291840"/>
+            <a:ext cx="10058400" cy="457200"/>
+          </a:xfrm>
+          <a:prstGeom prst="rect">
+            <a:avLst/>
+          </a:prstGeom>
+          <a:noFill/>
+        </p:spPr>
+        <p:txBody>
+          <a:bodyPr wrap="square" rtlCol="0"/>
+          <a:lstStyle/>
+          <a:p>
+            <a:pPr algn="l"/>
+            <a:r>
+              <a:rPr lang="en-US" sz="1500" dirty="0">
+                <a:solidFill>
+                  <a:srgbClr val="C7CFDB"/>
+                </a:solidFill>
+                <a:latin typeface="Calibri"/>
+              </a:rPr>
+              <a:t>19 July 2026 | HCA Series-A | 200 Marks | Only 15 Seats</a:t>
+            </a:r>
+          </a:p>
+        </p:txBody>
+      </p:sp>
+      <p:sp>
+        <p:nvSpPr>
+          <p:cNvPr id="0" name="B1"/>
+          <p:cNvSpPr/>
+          <p:nvPr/>
+        </p:nvSpPr>
+        <p:spPr>
+          <a:xfrm>
+            <a:off x="731520" y="4389120"/>
+            <a:ext cx="3200400" cy="1280160"/>
+          </a:xfrm>
+          <a:prstGeom prst="roundRect">
+            <a:avLst>
+              <a:gd name="adj" fmla="val 5000"/>
+            </a:avLst>
+          </a:prstGeom>
+          <a:solidFill>
+            <a:srgbClr val="2E4057"/>
+          </a:solidFill>
+          <a:ln>
+            <a:noFill/>
+          </a:ln>
+        </p:spPr>
+        <p:txBody>
+          <a:bodyPr/>
+          <a:lstStyle/>
+          <a:p>
+            <a:endParaRPr lang="en-US"/>
+          </a:p>
+        </p:txBody>
+      </p:sp>
+      <p:sp>
+        <p:nvSpPr>
+          <p:cNvPr id="0" name="TB"/>
+          <p:cNvSpPr txBox="1"/>
+          <p:nvPr/>
+        </p:nvSpPr>
+        <p:spPr>
+          <a:xfrm>
+            <a:off x="822960" y="4480560"/>
+            <a:ext cx="3017520" cy="1097280"/>
+          </a:xfrm>
+          <a:prstGeom prst="rect">
+            <a:avLst/>
+          </a:prstGeom>
+          <a:noFill/>
+        </p:spPr>
+        <p:txBody>
+          <a:bodyPr wrap="square" rtlCol="0"/>
+          <a:lstStyle/>
+          <a:p>
+            <a:pPr algn="ctr"/>
+            <a:r>
+              <a:rPr lang="en-US" sz="3600" b="1" dirty="0">
+                <a:solidFill>
+                  <a:srgbClr val="E0A458"/>
+                </a:solidFill>
+                <a:latin typeface="Calibri"/>
+              </a:rPr>
+              <a:t>200</a:t>
+            </a:r>
+          </a:p>
+          <a:p>
+            <a:pPr algn="ctr"/>
+            <a:r>
+              <a:rPr lang="en-US" sz="1200" dirty="0">
+                <a:solidFill>
+                  <a:srgbClr val="C7CFDB"/>
+                </a:solidFill>
+                <a:latin typeface="Calibri"/>
+              </a:rPr>
+              <a:t>Total Marks</a:t>
+            </a:r>
+          </a:p>
+        </p:txBody>
+      </p:sp>
+      <p:sp>
+        <p:nvSpPr>
+          <p:cNvPr id="0" name="B2"/>
+          <p:cNvSpPr/>
+          <p:nvPr/>
+        </p:nvSpPr>
+        <p:spPr>
+          <a:xfrm>
+            <a:off x="4206240" y="4389120"/>
+            <a:ext cx="3200400" cy="1280160"/>
+          </a:xfrm>
+          <a:prstGeom prst="roundRect">
+            <a:avLst>
+              <a:gd name="adj" fmla="val 5000"/>
+            </a:avLst>
+          </a:prstGeom>
+          <a:solidFill>
+            <a:srgbClr val="2E4057"/>
+          </a:solidFill>
+          <a:ln>
+            <a:noFill/>
+          </a:ln>
+        </p:spPr>
+        <p:txBody>
+          <a:bodyPr/>
+          <a:lstStyle/>
+          <a:p>
+            <a:endParaRPr lang="en-US"/>
+          </a:p>
+        </p:txBody>
+      </p:sp>
+      <p:sp>
+        <p:nvSpPr>
+          <p:cNvPr id="0" name="TB"/>
+          <p:cNvSpPr txBox="1"/>
+          <p:nvPr/>
+        </p:nvSpPr>
+        <p:spPr>
+          <a:xfrm>
+            <a:off x="4297680" y="4480560"/>
+            <a:ext cx="3017520" cy="1097280"/>
+          </a:xfrm>
+          <a:prstGeom prst="rect">
+            <a:avLst/>
+          </a:prstGeom>
+          <a:noFill/>
+        </p:spPr>
+        <p:txBody>
+          <a:bodyPr wrap="square" rtlCol="0"/>
+          <a:lstStyle/>
+          <a:p>
+            <a:pPr algn="ctr"/>
+            <a:r>
+              <a:rPr lang="en-US" sz="3600" b="1" dirty="0">
+                <a:solidFill>
+                  <a:srgbClr val="DC3545"/>
+                </a:solidFill>
+                <a:latin typeface="Calibri"/>
+              </a:rPr>
+              <a:t>15</a:t>
+            </a:r>
+          </a:p>
+          <a:p>
+            <a:pPr algn="ctr"/>
+            <a:r>
+              <a:rPr lang="en-US" sz="1200" dirty="0">
+                <a:solidFill>
+                  <a:srgbClr val="C7CFDB"/>
+                </a:solidFill>
+                <a:latin typeface="Calibri"/>
+              </a:rPr>
+              <a:t>Seats Only!</a:t>
+            </a:r>
+          </a:p>
+        </p:txBody>
+      </p:sp>
+      <p:sp>
+        <p:nvSpPr>
+          <p:cNvPr id="0" name="B3"/>
+          <p:cNvSpPr/>
+          <p:nvPr/>
+        </p:nvSpPr>
+        <p:spPr>
+          <a:xfrm>
+            <a:off x="7680960" y="4389120"/>
+            <a:ext cx="3200400" cy="1280160"/>
+          </a:xfrm>
+          <a:prstGeom prst="roundRect">
+            <a:avLst>
+              <a:gd name="adj" fmla="val 5000"/>
+            </a:avLst>
+          </a:prstGeom>
+          <a:solidFill>
+            <a:srgbClr val="2E4057"/>
+          </a:solidFill>
+          <a:ln>
+            <a:noFill/>
+          </a:ln>
+        </p:spPr>
+        <p:txBody>
+          <a:bodyPr/>
+          <a:lstStyle/>
+          <a:p>
+            <a:endParaRPr lang="en-US"/>
+          </a:p>
+        </p:txBody>
+      </p:sp>
+      <p:sp>
+        <p:nvSpPr>
+          <p:cNvPr id="0" name="TB"/>
+          <p:cNvSpPr txBox="1"/>
+          <p:nvPr/>
+        </p:nvSpPr>
+        <p:spPr>
+          <a:xfrm>
+            <a:off x="7772400" y="4480560"/>
+            <a:ext cx="3017520" cy="1097280"/>
+          </a:xfrm>
+          <a:prstGeom prst="rect">
+            <a:avLst/>
+          </a:prstGeom>
+          <a:noFill/>
+        </p:spPr>
+        <p:txBody>
+          <a:bodyPr wrap="square" rtlCol="0"/>
+          <a:lstStyle/>
+          <a:p>
+            <a:pPr algn="ctr"/>
+            <a:r>
+              <a:rPr lang="en-US" sz="3200" b="1" dirty="0">
+                <a:solidFill>
+                  <a:srgbClr val="E0A458"/>
+                </a:solidFill>
+                <a:latin typeface="Calibri"/>
+              </a:rPr>
+              <a:t>0.25</a:t>
+            </a:r>
+          </a:p>
+          <a:p>
+            <a:pPr algn="ctr"/>
+            <a:r>
+              <a:rPr lang="en-US" sz="1200" dirty="0">
+                <a:solidFill>
+                  <a:srgbClr val="C7CFDB"/>
+                </a:solidFill>
+                <a:latin typeface="Calibri"/>
+              </a:rPr>
+              <a:t>Negative/Wrong</a:t>
+            </a:r>
+          </a:p>
+        </p:txBody>
+      </p:sp>
+      <p:sp>
+        <p:nvSpPr>
+          <p:cNvPr id="0" name="Warn"/>
+          <p:cNvSpPr/>
+          <p:nvPr/>
+        </p:nvSpPr>
+        <p:spPr>
+          <a:xfrm>
+            <a:off x="731520" y="5943600"/>
+            <a:ext cx="10698480" cy="548640"/>
+          </a:xfrm>
+          <a:prstGeom prst="roundRect">
+            <a:avLst>
+              <a:gd name="adj" fmla="val 5000"/>
+            </a:avLst>
+          </a:prstGeom>
+          <a:solidFill>
+            <a:srgbClr val="DC3545"/>
+          </a:solidFill>
+          <a:ln>
+            <a:noFill/>
+          </a:ln>
+        </p:spPr>
+        <p:txBody>
+          <a:bodyPr/>
+          <a:lstStyle/>
+          <a:p>
+            <a:endParaRPr lang="en-US"/>
+          </a:p>
+        </p:txBody>
+      </p:sp>
+      <p:sp>
+        <p:nvSpPr>
+          <p:cNvPr id="0" name="TB"/>
+          <p:cNvSpPr txBox="1"/>
+          <p:nvPr/>
+        </p:nvSpPr>
+        <p:spPr>
+          <a:xfrm>
+            <a:off x="914400" y="5989320"/>
+            <a:ext cx="10332720" cy="457200"/>
+          </a:xfrm>
+          <a:prstGeom prst="rect">
+            <a:avLst/>
+          </a:prstGeom>
+          <a:noFill/>
+        </p:spPr>
+        <p:txBody>
+          <a:bodyPr wrap="square" rtlCol="0"/>
+          <a:lstStyle/>
+          <a:p>
+            <a:pPr algn="ctr"/>
+            <a:r>
+              <a:rPr lang="en-US" sz="1400" b="1" dirty="0">
+                <a:solidFill>
+                  <a:srgbClr val="FFFFFF"/>
+                </a:solidFill>
+                <a:latin typeface="Calibri"/>
+              </a:rPr>
+              <a:t>EXTREME COMPETITION: 15 Seats = Every Single Mark Counts!</a:t>
+            </a:r>
+          </a:p>
+        </p:txBody>
+      </p:sp>
     </p:spTree>
   </p:cSld>
-  <p:clrMapOvr><a:masterClrMapping/></p:clrMapOvr>
+  <p:clrMapOvr>
+    <a:masterClrMapping/>
+  </p:clrMapOvr>
 </p:sld>
 </file>
 
@@ -3634,342 +3967,1435 @@
 </p:sld>
 </file>
 
-<file path=ppt/slides/slide5.xml><?xml version="1.0" encoding="UTF-8" standalone="yes"?>
-<p:sld xmlns:a="http://schemas.openxmlformats.org/drawingml/2006/main"
-       xmlns:r="http://schemas.openxmlformats.org/officeDocument/2006/relationships"
-       xmlns:p="http://schemas.openxmlformats.org/presentationml/2006/main">
+<file path=ppt/slides/slide5.xml><?xml version="1.0" encoding="utf-8"?>
+<p:sld xmlns:a="http://schemas.openxmlformats.org/drawingml/2006/main" xmlns:r="http://schemas.openxmlformats.org/officeDocument/2006/relationships" xmlns:p="http://schemas.openxmlformats.org/presentationml/2006/main">
   <p:cSld>
-    <p:bg><p:bgPr><a:solidFill><a:srgbClr val="16233A"/></a:solidFill><a:effectLst/></p:bgPr></p:bg>
+    <p:bg>
+      <p:bgPr>
+        <a:solidFill>
+          <a:srgbClr val="16233A"/>
+        </a:solidFill>
+        <a:effectLst/>
+      </p:bgPr>
+    </p:bg>
     <p:spTree>
-      <p:nvGrpSpPr><p:cNvPr id="1" name=""/><p:cNvGrpSpPr/><p:nvPr/></p:nvGrpSpPr>
+      <p:nvGrpSpPr>
+        <p:cNvPr id="1" name=""/>
+        <p:cNvGrpSpPr/>
+        <p:nvPr/>
+      </p:nvGrpSpPr>
       <p:grpSpPr>
-        <a:xfrm><a:off x="0" y="0"/><a:ext cx="0" cy="0"/><a:chOff x="0" y="0"/><a:chExt cx="0" cy="0"/></a:xfrm>
+        <a:xfrm>
+          <a:off x="0" y="0"/>
+          <a:ext cx="0" cy="0"/>
+          <a:chOff x="0" y="0"/>
+          <a:chExt cx="0" cy="0"/>
+        </a:xfrm>
       </p:grpSpPr>
       <p:sp>
-  <p:nvSpPr><p:cNvPr id="0" name="TB"/><p:cNvSpPr txBox="1"/><p:nvPr/></p:nvSpPr>
-  <p:spPr>
-    <a:xfrm><a:off x="640080" y="274320"/><a:ext cx="10972800" cy="548640"/></a:xfrm>
-    <a:prstGeom prst="rect"><a:avLst/></a:prstGeom><a:noFill/>
-  </p:spPr>
-  <p:txBody><a:bodyPr wrap="square" rtlCol="0"/><a:lstStyle/><a:p><a:pPr algn="l"/><a:r><a:rPr lang="en-US" sz="2500" b="1" dirty="0"><a:solidFill><a:srgbClr val="FFFFFF"/></a:solidFill><a:latin typeface="Calibri"/></a:rPr><a:t>Current Affairs — Answer Key Highlights</a:t></a:r></a:p></p:txBody>
-</p:sp><p:sp>
-  <p:nvSpPr><p:cNvPr id="0" name="TB"/><p:cNvSpPr txBox="1"/><p:nvPr/></p:nvSpPr>
-  <p:spPr>
-    <a:xfrm><a:off x="640080" y="731520"/><a:ext cx="10972800" cy="365760"/></a:xfrm>
-    <a:prstGeom prst="rect"><a:avLst/></a:prstGeom><a:noFill/>
-  </p:spPr>
-  <p:txBody><a:bodyPr wrap="square" rtlCol="0"/><a:lstStyle/><a:p><a:pPr algn="l"/><a:r><a:rPr lang="en-US" sz="1300" dirty="0"><a:solidFill><a:srgbClr val="C7CFDB"/></a:solidFill><a:latin typeface="Calibri"/></a:rPr><a:t>Q177-Q195: National & International Current Affairs</a:t></a:r></a:p></p:txBody>
-</p:sp><p:sp>
-  <p:nvSpPr><p:cNvPr id="0" name="CH"/><p:cNvSpPr/><p:nvPr/></p:nvSpPr>
-  <p:spPr>
-    <a:xfrm><a:off x="640080" y="1188720"/><a:ext cx="10698480" cy="457200"/></a:xfrm>
-    <a:prstGeom prst="roundRect"><a:avLst><a:gd name="adj" fmla="val 5000"/></a:avLst></a:prstGeom>
-    <a:solidFill><a:srgbClr val="2E4057"/></a:solidFill>
-    <a:ln><a:noFill/></a:ln>
-  </p:spPr>
-  <p:txBody><a:bodyPr/><a:lstStyle/><a:p><a:endParaRPr lang="en-US"/></a:p></p:txBody>
-</p:sp><p:sp>
-  <p:nvSpPr><p:cNvPr id="0" name="TB"/><p:cNvSpPr txBox="1"/><p:nvPr/></p:nvSpPr>
-  <p:spPr>
-    <a:xfrm><a:off x="822960" y="1216152"/><a:ext cx="1371600" cy="411480"/></a:xfrm>
-    <a:prstGeom prst="rect"><a:avLst/></a:prstGeom><a:noFill/>
-  </p:spPr>
-  <p:txBody><a:bodyPr wrap="square" rtlCol="0"/><a:lstStyle/><a:p><a:pPr algn="l"/><a:r><a:rPr lang="en-US" sz="1100" b="1" dirty="0"><a:solidFill><a:srgbClr val="FFFFFF"/></a:solidFill><a:latin typeface="Calibri"/></a:rPr><a:t>Q#</a:t></a:r></a:p></p:txBody>
-</p:sp><p:sp>
-  <p:nvSpPr><p:cNvPr id="0" name="TB"/><p:cNvSpPr txBox="1"/><p:nvPr/></p:nvSpPr>
-  <p:spPr>
-    <a:xfrm><a:off x="2286000" y="1216152"/><a:ext cx="4572000" cy="411480"/></a:xfrm>
-    <a:prstGeom prst="rect"><a:avLst/></a:prstGeom><a:noFill/>
-  </p:spPr>
-  <p:txBody><a:bodyPr wrap="square" rtlCol="0"/><a:lstStyle/><a:p><a:pPr algn="l"/><a:r><a:rPr lang="en-US" sz="1100" b="1" dirty="0"><a:solidFill><a:srgbClr val="FFFFFF"/></a:solidFill><a:latin typeface="Calibri"/></a:rPr><a:t>Topic</a:t></a:r></a:p></p:txBody>
-</p:sp><p:sp>
-  <p:nvSpPr><p:cNvPr id="0" name="TB"/><p:cNvSpPr txBox="1"/><p:nvPr/></p:nvSpPr>
-  <p:spPr>
-    <a:xfrm><a:off x="7315200" y="1216152"/><a:ext cx="3840480" cy="411480"/></a:xfrm>
-    <a:prstGeom prst="rect"><a:avLst/></a:prstGeom><a:noFill/>
-  </p:spPr>
-  <p:txBody><a:bodyPr wrap="square" rtlCol="0"/><a:lstStyle/><a:p><a:pPr algn="l"/><a:r><a:rPr lang="en-US" sz="1100" b="1" dirty="0"><a:solidFill><a:srgbClr val="E0A458"/></a:solidFill><a:latin typeface="Calibri"/></a:rPr><a:t>Answer</a:t></a:r></a:p></p:txBody>
-</p:sp><p:sp>
-  <p:nvSpPr><p:cNvPr id="0" name="CA0"/><p:cNvSpPr/><p:nvPr/></p:nvSpPr>
-  <p:spPr>
-    <a:xfrm><a:off x="640080" y="1737360"/><a:ext cx="10698480" cy="438912"/></a:xfrm>
-    <a:prstGeom prst="roundRect"><a:avLst><a:gd name="adj" fmla="val 5000"/></a:avLst></a:prstGeom>
-    <a:solidFill><a:srgbClr val="16233A"/></a:solidFill>
-    <a:ln><a:noFill/></a:ln>
-  </p:spPr>
-  <p:txBody><a:bodyPr/><a:lstStyle/><a:p><a:endParaRPr lang="en-US"/></a:p></p:txBody>
-</p:sp><p:sp>
-  <p:nvSpPr><p:cNvPr id="0" name="TB"/><p:cNvSpPr txBox="1"/><p:nvPr/></p:nvSpPr>
-  <p:spPr>
-    <a:xfrm><a:off x="822960" y="1764792"/><a:ext cx="1371600" cy="384048"/></a:xfrm>
-    <a:prstGeom prst="rect"><a:avLst/></a:prstGeom><a:noFill/>
-  </p:spPr>
-  <p:txBody><a:bodyPr wrap="square" rtlCol="0"/><a:lstStyle/><a:p><a:pPr algn="l"/><a:r><a:rPr lang="en-US" sz="1100" dirty="0"><a:solidFill><a:srgbClr val="C7CFDB"/></a:solidFill><a:latin typeface="Calibri"/></a:rPr><a:t>Q178</a:t></a:r></a:p></p:txBody>
-</p:sp><p:sp>
-  <p:nvSpPr><p:cNvPr id="0" name="TB"/><p:cNvSpPr txBox="1"/><p:nvPr/></p:nvSpPr>
-  <p:spPr>
-    <a:xfrm><a:off x="2286000" y="1764792"/><a:ext cx="4572000" cy="384048"/></a:xfrm>
-    <a:prstGeom prst="rect"><a:avLst/></a:prstGeom><a:noFill/>
-  </p:spPr>
-  <p:txBody><a:bodyPr wrap="square" rtlCol="0"/><a:lstStyle/><a:p><a:pPr algn="l"/><a:r><a:rPr lang="en-US" sz="1100" dirty="0"><a:solidFill><a:srgbClr val="FFFFFF"/></a:solidFill><a:latin typeface="Calibri"/></a:rPr><a:t>WEF Davos 2026 Theme</a:t></a:r></a:p></p:txBody>
-</p:sp><p:sp>
-  <p:nvSpPr><p:cNvPr id="0" name="TB"/><p:cNvSpPr txBox="1"/><p:nvPr/></p:nvSpPr>
-  <p:spPr>
-    <a:xfrm><a:off x="7315200" y="1764792"/><a:ext cx="3840480" cy="384048"/></a:xfrm>
-    <a:prstGeom prst="rect"><a:avLst/></a:prstGeom><a:noFill/>
-  </p:spPr>
-  <p:txBody><a:bodyPr wrap="square" rtlCol="0"/><a:lstStyle/><a:p><a:pPr algn="l"/><a:r><a:rPr lang="en-US" sz="1100" b="1" dirty="0"><a:solidFill><a:srgbClr val="E0A458"/></a:solidFill><a:latin typeface="Calibri"/></a:rPr><a:t>Cooperation in a Fragmented World</a:t></a:r></a:p></p:txBody>
-</p:sp><p:sp>
-  <p:nvSpPr><p:cNvPr id="0" name="CA1"/><p:cNvSpPr/><p:nvPr/></p:nvSpPr>
-  <p:spPr>
-    <a:xfrm><a:off x="640080" y="2212848"/><a:ext cx="10698480" cy="438912"/></a:xfrm>
-    <a:prstGeom prst="roundRect"><a:avLst><a:gd name="adj" fmla="val 5000"/></a:avLst></a:prstGeom>
-    <a:solidFill><a:srgbClr val="2E4057"/></a:solidFill>
-    <a:ln><a:noFill/></a:ln>
-  </p:spPr>
-  <p:txBody><a:bodyPr/><a:lstStyle/><a:p><a:endParaRPr lang="en-US"/></a:p></p:txBody>
-</p:sp><p:sp>
-  <p:nvSpPr><p:cNvPr id="0" name="TB"/><p:cNvSpPr txBox="1"/><p:nvPr/></p:nvSpPr>
-  <p:spPr>
-    <a:xfrm><a:off x="822960" y="2240280"/><a:ext cx="1371600" cy="384048"/></a:xfrm>
-    <a:prstGeom prst="rect"><a:avLst/></a:prstGeom><a:noFill/>
-  </p:spPr>
-  <p:txBody><a:bodyPr wrap="square" rtlCol="0"/><a:lstStyle/><a:p><a:pPr algn="l"/><a:r><a:rPr lang="en-US" sz="1100" dirty="0"><a:solidFill><a:srgbClr val="C7CFDB"/></a:solidFill><a:latin typeface="Calibri"/></a:rPr><a:t>Q179</a:t></a:r></a:p></p:txBody>
-</p:sp><p:sp>
-  <p:nvSpPr><p:cNvPr id="0" name="TB"/><p:cNvSpPr txBox="1"/><p:nvPr/></p:nvSpPr>
-  <p:spPr>
-    <a:xfrm><a:off x="2286000" y="2240280"/><a:ext cx="4572000" cy="384048"/></a:xfrm>
-    <a:prstGeom prst="rect"><a:avLst/></a:prstGeom><a:noFill/>
-  </p:spPr>
-  <p:txBody><a:bodyPr wrap="square" rtlCol="0"/><a:lstStyle/><a:p><a:pPr algn="l"/><a:r><a:rPr lang="en-US" sz="1100" dirty="0"><a:solidFill><a:srgbClr val="FFFFFF"/></a:solidFill><a:latin typeface="Calibri"/></a:rPr><a:t>EU Council President</a:t></a:r></a:p></p:txBody>
-</p:sp><p:sp>
-  <p:nvSpPr><p:cNvPr id="0" name="TB"/><p:cNvSpPr txBox="1"/><p:nvPr/></p:nvSpPr>
-  <p:spPr>
-    <a:xfrm><a:off x="7315200" y="2240280"/><a:ext cx="3840480" cy="384048"/></a:xfrm>
-    <a:prstGeom prst="rect"><a:avLst/></a:prstGeom><a:noFill/>
-  </p:spPr>
-  <p:txBody><a:bodyPr wrap="square" rtlCol="0"/><a:lstStyle/><a:p><a:pPr algn="l"/><a:r><a:rPr lang="en-US" sz="1100" b="1" dirty="0"><a:solidFill><a:srgbClr val="E0A458"/></a:solidFill><a:latin typeface="Calibri"/></a:rPr><a:t>Antonio Costa</a:t></a:r></a:p></p:txBody>
-</p:sp><p:sp>
-  <p:nvSpPr><p:cNvPr id="0" name="CA2"/><p:cNvSpPr/><p:nvPr/></p:nvSpPr>
-  <p:spPr>
-    <a:xfrm><a:off x="640080" y="2688336"/><a:ext cx="10698480" cy="438912"/></a:xfrm>
-    <a:prstGeom prst="roundRect"><a:avLst><a:gd name="adj" fmla="val 5000"/></a:avLst></a:prstGeom>
-    <a:solidFill><a:srgbClr val="16233A"/></a:solidFill>
-    <a:ln><a:noFill/></a:ln>
-  </p:spPr>
-  <p:txBody><a:bodyPr/><a:lstStyle/><a:p><a:endParaRPr lang="en-US"/></a:p></p:txBody>
-</p:sp><p:sp>
-  <p:nvSpPr><p:cNvPr id="0" name="TB"/><p:cNvSpPr txBox="1"/><p:nvPr/></p:nvSpPr>
-  <p:spPr>
-    <a:xfrm><a:off x="822960" y="2715768"/><a:ext cx="1371600" cy="384048"/></a:xfrm>
-    <a:prstGeom prst="rect"><a:avLst/></a:prstGeom><a:noFill/>
-  </p:spPr>
-  <p:txBody><a:bodyPr wrap="square" rtlCol="0"/><a:lstStyle/><a:p><a:pPr algn="l"/><a:r><a:rPr lang="en-US" sz="1100" dirty="0"><a:solidFill><a:srgbClr val="C7CFDB"/></a:solidFill><a:latin typeface="Calibri"/></a:rPr><a:t>Q181</a:t></a:r></a:p></p:txBody>
-</p:sp><p:sp>
-  <p:nvSpPr><p:cNvPr id="0" name="TB"/><p:cNvSpPr txBox="1"/><p:nvPr/></p:nvSpPr>
-  <p:spPr>
-    <a:xfrm><a:off x="2286000" y="2715768"/><a:ext cx="4572000" cy="384048"/></a:xfrm>
-    <a:prstGeom prst="rect"><a:avLst/></a:prstGeom><a:noFill/>
-  </p:spPr>
-  <p:txBody><a:bodyPr wrap="square" rtlCol="0"/><a:lstStyle/><a:p><a:pPr algn="l"/><a:r><a:rPr lang="en-US" sz="1100" dirty="0"><a:solidFill><a:srgbClr val="FFFFFF"/></a:solidFill><a:latin typeface="Calibri"/></a:rPr><a:t>Nobel Peace Prize 2025</a:t></a:r></a:p></p:txBody>
-</p:sp><p:sp>
-  <p:nvSpPr><p:cNvPr id="0" name="TB"/><p:cNvSpPr txBox="1"/><p:nvPr/></p:nvSpPr>
-  <p:spPr>
-    <a:xfrm><a:off x="7315200" y="2715768"/><a:ext cx="3840480" cy="384048"/></a:xfrm>
-    <a:prstGeom prst="rect"><a:avLst/></a:prstGeom><a:noFill/>
-  </p:spPr>
-  <p:txBody><a:bodyPr wrap="square" rtlCol="0"/><a:lstStyle/><a:p><a:pPr algn="l"/><a:r><a:rPr lang="en-US" sz="1100" b="1" dirty="0"><a:solidFill><a:srgbClr val="E0A458"/></a:solidFill><a:latin typeface="Calibri"/></a:rPr><a:t>Nihon Hidankyo</a:t></a:r></a:p></p:txBody>
-</p:sp><p:sp>
-  <p:nvSpPr><p:cNvPr id="0" name="CA3"/><p:cNvSpPr/><p:nvPr/></p:nvSpPr>
-  <p:spPr>
-    <a:xfrm><a:off x="640080" y="3163824"/><a:ext cx="10698480" cy="438912"/></a:xfrm>
-    <a:prstGeom prst="roundRect"><a:avLst><a:gd name="adj" fmla="val 5000"/></a:avLst></a:prstGeom>
-    <a:solidFill><a:srgbClr val="2E4057"/></a:solidFill>
-    <a:ln><a:noFill/></a:ln>
-  </p:spPr>
-  <p:txBody><a:bodyPr/><a:lstStyle/><a:p><a:endParaRPr lang="en-US"/></a:p></p:txBody>
-</p:sp><p:sp>
-  <p:nvSpPr><p:cNvPr id="0" name="TB"/><p:cNvSpPr txBox="1"/><p:nvPr/></p:nvSpPr>
-  <p:spPr>
-    <a:xfrm><a:off x="822960" y="3191256"/><a:ext cx="1371600" cy="384048"/></a:xfrm>
-    <a:prstGeom prst="rect"><a:avLst/></a:prstGeom><a:noFill/>
-  </p:spPr>
-  <p:txBody><a:bodyPr wrap="square" rtlCol="0"/><a:lstStyle/><a:p><a:pPr algn="l"/><a:r><a:rPr lang="en-US" sz="1100" dirty="0"><a:solidFill><a:srgbClr val="C7CFDB"/></a:solidFill><a:latin typeface="Calibri"/></a:rPr><a:t>Q183</a:t></a:r></a:p></p:txBody>
-</p:sp><p:sp>
-  <p:nvSpPr><p:cNvPr id="0" name="TB"/><p:cNvSpPr txBox="1"/><p:nvPr/></p:nvSpPr>
-  <p:spPr>
-    <a:xfrm><a:off x="2286000" y="3191256"/><a:ext cx="4572000" cy="384048"/></a:xfrm>
-    <a:prstGeom prst="rect"><a:avLst/></a:prstGeom><a:noFill/>
-  </p:spPr>
-  <p:txBody><a:bodyPr wrap="square" rtlCol="0"/><a:lstStyle/><a:p><a:pPr algn="l"/><a:r><a:rPr lang="en-US" sz="1100" dirty="0"><a:solidFill><a:srgbClr val="FFFFFF"/></a:solidFill><a:latin typeface="Calibri"/></a:rPr><a:t>IOAA 2026 Host</a:t></a:r></a:p></p:txBody>
-</p:sp><p:sp>
-  <p:nvSpPr><p:cNvPr id="0" name="TB"/><p:cNvSpPr txBox="1"/><p:nvPr/></p:nvSpPr>
-  <p:spPr>
-    <a:xfrm><a:off x="7315200" y="3191256"/><a:ext cx="3840480" cy="384048"/></a:xfrm>
-    <a:prstGeom prst="rect"><a:avLst/></a:prstGeom><a:noFill/>
-  </p:spPr>
-  <p:txBody><a:bodyPr wrap="square" rtlCol="0"/><a:lstStyle/><a:p><a:pPr algn="l"/><a:r><a:rPr lang="en-US" sz="1100" b="1" dirty="0"><a:solidFill><a:srgbClr val="E0A458"/></a:solidFill><a:latin typeface="Calibri"/></a:rPr><a:t>Mumbai, India</a:t></a:r></a:p></p:txBody>
-</p:sp><p:sp>
-  <p:nvSpPr><p:cNvPr id="0" name="CA4"/><p:cNvSpPr/><p:nvPr/></p:nvSpPr>
-  <p:spPr>
-    <a:xfrm><a:off x="640080" y="3639312"/><a:ext cx="10698480" cy="438912"/></a:xfrm>
-    <a:prstGeom prst="roundRect"><a:avLst><a:gd name="adj" fmla="val 5000"/></a:avLst></a:prstGeom>
-    <a:solidFill><a:srgbClr val="16233A"/></a:solidFill>
-    <a:ln><a:noFill/></a:ln>
-  </p:spPr>
-  <p:txBody><a:bodyPr/><a:lstStyle/><a:p><a:endParaRPr lang="en-US"/></a:p></p:txBody>
-</p:sp><p:sp>
-  <p:nvSpPr><p:cNvPr id="0" name="TB"/><p:cNvSpPr txBox="1"/><p:nvPr/></p:nvSpPr>
-  <p:spPr>
-    <a:xfrm><a:off x="822960" y="3666744"/><a:ext cx="1371600" cy="384048"/></a:xfrm>
-    <a:prstGeom prst="rect"><a:avLst/></a:prstGeom><a:noFill/>
-  </p:spPr>
-  <p:txBody><a:bodyPr wrap="square" rtlCol="0"/><a:lstStyle/><a:p><a:pPr algn="l"/><a:r><a:rPr lang="en-US" sz="1100" dirty="0"><a:solidFill><a:srgbClr val="C7CFDB"/></a:solidFill><a:latin typeface="Calibri"/></a:rPr><a:t>Q184</a:t></a:r></a:p></p:txBody>
-</p:sp><p:sp>
-  <p:nvSpPr><p:cNvPr id="0" name="TB"/><p:cNvSpPr txBox="1"/><p:nvPr/></p:nvSpPr>
-  <p:spPr>
-    <a:xfrm><a:off x="2286000" y="3666744"/><a:ext cx="4572000" cy="384048"/></a:xfrm>
-    <a:prstGeom prst="rect"><a:avLst/></a:prstGeom><a:noFill/>
-  </p:spPr>
-  <p:txBody><a:bodyPr wrap="square" rtlCol="0"/><a:lstStyle/><a:p><a:pPr algn="l"/><a:r><a:rPr lang="en-US" sz="1100" dirty="0"><a:solidFill><a:srgbClr val="FFFFFF"/></a:solidFill><a:latin typeface="Calibri"/></a:rPr><a:t>Sri Lanka PM</a:t></a:r></a:p></p:txBody>
-</p:sp><p:sp>
-  <p:nvSpPr><p:cNvPr id="0" name="TB"/><p:cNvSpPr txBox="1"/><p:nvPr/></p:nvSpPr>
-  <p:spPr>
-    <a:xfrm><a:off x="7315200" y="3666744"/><a:ext cx="3840480" cy="384048"/></a:xfrm>
-    <a:prstGeom prst="rect"><a:avLst/></a:prstGeom><a:noFill/>
-  </p:spPr>
-  <p:txBody><a:bodyPr wrap="square" rtlCol="0"/><a:lstStyle/><a:p><a:pPr algn="l"/><a:r><a:rPr lang="en-US" sz="1100" b="1" dirty="0"><a:solidFill><a:srgbClr val="E0A458"/></a:solidFill><a:latin typeface="Calibri"/></a:rPr><a:t>Harini Amarasuriya</a:t></a:r></a:p></p:txBody>
-</p:sp><p:sp>
-  <p:nvSpPr><p:cNvPr id="0" name="CA5"/><p:cNvSpPr/><p:nvPr/></p:nvSpPr>
-  <p:spPr>
-    <a:xfrm><a:off x="640080" y="4114800"/><a:ext cx="10698480" cy="438912"/></a:xfrm>
-    <a:prstGeom prst="roundRect"><a:avLst><a:gd name="adj" fmla="val 5000"/></a:avLst></a:prstGeom>
-    <a:solidFill><a:srgbClr val="2E4057"/></a:solidFill>
-    <a:ln><a:noFill/></a:ln>
-  </p:spPr>
-  <p:txBody><a:bodyPr/><a:lstStyle/><a:p><a:endParaRPr lang="en-US"/></a:p></p:txBody>
-</p:sp><p:sp>
-  <p:nvSpPr><p:cNvPr id="0" name="TB"/><p:cNvSpPr txBox="1"/><p:nvPr/></p:nvSpPr>
-  <p:spPr>
-    <a:xfrm><a:off x="822960" y="4142232"/><a:ext cx="1371600" cy="384048"/></a:xfrm>
-    <a:prstGeom prst="rect"><a:avLst/></a:prstGeom><a:noFill/>
-  </p:spPr>
-  <p:txBody><a:bodyPr wrap="square" rtlCol="0"/><a:lstStyle/><a:p><a:pPr algn="l"/><a:r><a:rPr lang="en-US" sz="1100" dirty="0"><a:solidFill><a:srgbClr val="C7CFDB"/></a:solidFill><a:latin typeface="Calibri"/></a:rPr><a:t>Q186</a:t></a:r></a:p></p:txBody>
-</p:sp><p:sp>
-  <p:nvSpPr><p:cNvPr id="0" name="TB"/><p:cNvSpPr txBox="1"/><p:nvPr/></p:nvSpPr>
-  <p:spPr>
-    <a:xfrm><a:off x="2286000" y="4142232"/><a:ext cx="4572000" cy="384048"/></a:xfrm>
-    <a:prstGeom prst="rect"><a:avLst/></a:prstGeom><a:noFill/>
-  </p:spPr>
-  <p:txBody><a:bodyPr wrap="square" rtlCol="0"/><a:lstStyle/><a:p><a:pPr algn="l"/><a:r><a:rPr lang="en-US" sz="1100" dirty="0"><a:solidFill><a:srgbClr val="FFFFFF"/></a:solidFill><a:latin typeface="Calibri"/></a:rPr><a:t>IWD 2026 Theme</a:t></a:r></a:p></p:txBody>
-</p:sp><p:sp>
-  <p:nvSpPr><p:cNvPr id="0" name="TB"/><p:cNvSpPr txBox="1"/><p:nvPr/></p:nvSpPr>
-  <p:spPr>
-    <a:xfrm><a:off x="7315200" y="4142232"/><a:ext cx="3840480" cy="384048"/></a:xfrm>
-    <a:prstGeom prst="rect"><a:avLst/></a:prstGeom><a:noFill/>
-  </p:spPr>
-  <p:txBody><a:bodyPr wrap="square" rtlCol="0"/><a:lstStyle/><a:p><a:pPr algn="l"/><a:r><a:rPr lang="en-US" sz="1100" b="1" dirty="0"><a:solidFill><a:srgbClr val="E0A458"/></a:solidFill><a:latin typeface="Calibri"/></a:rPr><a:t>Rights, Justice & Action</a:t></a:r></a:p></p:txBody>
-</p:sp><p:sp>
-  <p:nvSpPr><p:cNvPr id="0" name="CA6"/><p:cNvSpPr/><p:nvPr/></p:nvSpPr>
-  <p:spPr>
-    <a:xfrm><a:off x="640080" y="4590288"/><a:ext cx="10698480" cy="438912"/></a:xfrm>
-    <a:prstGeom prst="roundRect"><a:avLst><a:gd name="adj" fmla="val 5000"/></a:avLst></a:prstGeom>
-    <a:solidFill><a:srgbClr val="16233A"/></a:solidFill>
-    <a:ln><a:noFill/></a:ln>
-  </p:spPr>
-  <p:txBody><a:bodyPr/><a:lstStyle/><a:p><a:endParaRPr lang="en-US"/></a:p></p:txBody>
-</p:sp><p:sp>
-  <p:nvSpPr><p:cNvPr id="0" name="TB"/><p:cNvSpPr txBox="1"/><p:nvPr/></p:nvSpPr>
-  <p:spPr>
-    <a:xfrm><a:off x="822960" y="4617720"/><a:ext cx="1371600" cy="384048"/></a:xfrm>
-    <a:prstGeom prst="rect"><a:avLst/></a:prstGeom><a:noFill/>
-  </p:spPr>
-  <p:txBody><a:bodyPr wrap="square" rtlCol="0"/><a:lstStyle/><a:p><a:pPr algn="l"/><a:r><a:rPr lang="en-US" sz="1100" dirty="0"><a:solidFill><a:srgbClr val="C7CFDB"/></a:solidFill><a:latin typeface="Calibri"/></a:rPr><a:t>Q189</a:t></a:r></a:p></p:txBody>
-</p:sp><p:sp>
-  <p:nvSpPr><p:cNvPr id="0" name="TB"/><p:cNvSpPr txBox="1"/><p:nvPr/></p:nvSpPr>
-  <p:spPr>
-    <a:xfrm><a:off x="2286000" y="4617720"/><a:ext cx="4572000" cy="384048"/></a:xfrm>
-    <a:prstGeom prst="rect"><a:avLst/></a:prstGeom><a:noFill/>
-  </p:spPr>
-  <p:txBody><a:bodyPr wrap="square" rtlCol="0"/><a:lstStyle/><a:p><a:pPr algn="l"/><a:r><a:rPr lang="en-US" sz="1100" dirty="0"><a:solidFill><a:srgbClr val="FFFFFF"/></a:solidFill><a:latin typeface="Calibri"/></a:rPr><a:t>1971 War Film (Jan 2026)</a:t></a:r></a:p></p:txBody>
-</p:sp><p:sp>
-  <p:nvSpPr><p:cNvPr id="0" name="TB"/><p:cNvSpPr txBox="1"/><p:nvPr/></p:nvSpPr>
-  <p:spPr>
-    <a:xfrm><a:off x="7315200" y="4617720"/><a:ext cx="3840480" cy="384048"/></a:xfrm>
-    <a:prstGeom prst="rect"><a:avLst/></a:prstGeom><a:noFill/>
-  </p:spPr>
-  <p:txBody><a:bodyPr wrap="square" rtlCol="0"/><a:lstStyle/><a:p><a:pPr algn="l"/><a:r><a:rPr lang="en-US" sz="1100" b="1" dirty="0"><a:solidFill><a:srgbClr val="E0A458"/></a:solidFill><a:latin typeface="Calibri"/></a:rPr><a:t>Ikkees (Arun Khetarpal)</a:t></a:r></a:p></p:txBody>
-</p:sp><p:sp>
-  <p:nvSpPr><p:cNvPr id="0" name="CA7"/><p:cNvSpPr/><p:nvPr/></p:nvSpPr>
-  <p:spPr>
-    <a:xfrm><a:off x="640080" y="5065776"/><a:ext cx="10698480" cy="438912"/></a:xfrm>
-    <a:prstGeom prst="roundRect"><a:avLst><a:gd name="adj" fmla="val 5000"/></a:avLst></a:prstGeom>
-    <a:solidFill><a:srgbClr val="2E4057"/></a:solidFill>
-    <a:ln><a:noFill/></a:ln>
-  </p:spPr>
-  <p:txBody><a:bodyPr/><a:lstStyle/><a:p><a:endParaRPr lang="en-US"/></a:p></p:txBody>
-</p:sp><p:sp>
-  <p:nvSpPr><p:cNvPr id="0" name="TB"/><p:cNvSpPr txBox="1"/><p:nvPr/></p:nvSpPr>
-  <p:spPr>
-    <a:xfrm><a:off x="822960" y="5093208"/><a:ext cx="1371600" cy="384048"/></a:xfrm>
-    <a:prstGeom prst="rect"><a:avLst/></a:prstGeom><a:noFill/>
-  </p:spPr>
-  <p:txBody><a:bodyPr wrap="square" rtlCol="0"/><a:lstStyle/><a:p><a:pPr algn="l"/><a:r><a:rPr lang="en-US" sz="1100" dirty="0"><a:solidFill><a:srgbClr val="C7CFDB"/></a:solidFill><a:latin typeface="Calibri"/></a:rPr><a:t>Q192</a:t></a:r></a:p></p:txBody>
-</p:sp><p:sp>
-  <p:nvSpPr><p:cNvPr id="0" name="TB"/><p:cNvSpPr txBox="1"/><p:nvPr/></p:nvSpPr>
-  <p:spPr>
-    <a:xfrm><a:off x="2286000" y="5093208"/><a:ext cx="4572000" cy="384048"/></a:xfrm>
-    <a:prstGeom prst="rect"><a:avLst/></a:prstGeom><a:noFill/>
-  </p:spPr>
-  <p:txBody><a:bodyPr wrap="square" rtlCol="0"/><a:lstStyle/><a:p><a:pPr algn="l"/><a:r><a:rPr lang="en-US" sz="1100" dirty="0"><a:solidFill><a:srgbClr val="FFFFFF"/></a:solidFill><a:latin typeface="Calibri"/></a:rPr><a:t>Indian Fighter Jet 25th Anniv.</a:t></a:r></a:p></p:txBody>
-</p:sp><p:sp>
-  <p:nvSpPr><p:cNvPr id="0" name="TB"/><p:cNvSpPr txBox="1"/><p:nvPr/></p:nvSpPr>
-  <p:spPr>
-    <a:xfrm><a:off x="7315200" y="5093208"/><a:ext cx="3840480" cy="384048"/></a:xfrm>
-    <a:prstGeom prst="rect"><a:avLst/></a:prstGeom><a:noFill/>
-  </p:spPr>
-  <p:txBody><a:bodyPr wrap="square" rtlCol="0"/><a:lstStyle/><a:p><a:pPr algn="l"/><a:r><a:rPr lang="en-US" sz="1100" b="1" dirty="0"><a:solidFill><a:srgbClr val="E0A458"/></a:solidFill><a:latin typeface="Calibri"/></a:rPr><a:t>Tejas</a:t></a:r></a:p></p:txBody>
-</p:sp><p:sp>
-  <p:nvSpPr><p:cNvPr id="0" name="CA8"/><p:cNvSpPr/><p:nvPr/></p:nvSpPr>
-  <p:spPr>
-    <a:xfrm><a:off x="640080" y="5541264"/><a:ext cx="10698480" cy="438912"/></a:xfrm>
-    <a:prstGeom prst="roundRect"><a:avLst><a:gd name="adj" fmla="val 5000"/></a:avLst></a:prstGeom>
-    <a:solidFill><a:srgbClr val="16233A"/></a:solidFill>
-    <a:ln><a:noFill/></a:ln>
-  </p:spPr>
-  <p:txBody><a:bodyPr/><a:lstStyle/><a:p><a:endParaRPr lang="en-US"/></a:p></p:txBody>
-</p:sp><p:sp>
-  <p:nvSpPr><p:cNvPr id="0" name="TB"/><p:cNvSpPr txBox="1"/><p:nvPr/></p:nvSpPr>
-  <p:spPr>
-    <a:xfrm><a:off x="822960" y="5568696"/><a:ext cx="1371600" cy="384048"/></a:xfrm>
-    <a:prstGeom prst="rect"><a:avLst/></a:prstGeom><a:noFill/>
-  </p:spPr>
-  <p:txBody><a:bodyPr wrap="square" rtlCol="0"/><a:lstStyle/><a:p><a:pPr algn="l"/><a:r><a:rPr lang="en-US" sz="1100" dirty="0"><a:solidFill><a:srgbClr val="C7CFDB"/></a:solidFill><a:latin typeface="Calibri"/></a:rPr><a:t>Q193</a:t></a:r></a:p></p:txBody>
-</p:sp><p:sp>
-  <p:nvSpPr><p:cNvPr id="0" name="TB"/><p:cNvSpPr txBox="1"/><p:nvPr/></p:nvSpPr>
-  <p:spPr>
-    <a:xfrm><a:off x="2286000" y="5568696"/><a:ext cx="4572000" cy="384048"/></a:xfrm>
-    <a:prstGeom prst="rect"><a:avLst/></a:prstGeom><a:noFill/>
-  </p:spPr>
-  <p:txBody><a:bodyPr wrap="square" rtlCol="0"/><a:lstStyle/><a:p><a:pPr algn="l"/><a:r><a:rPr lang="en-US" sz="1100" dirty="0"><a:solidFill><a:srgbClr val="FFFFFF"/></a:solidFill><a:latin typeface="Calibri"/></a:rPr><a:t>39th National Games</a:t></a:r></a:p></p:txBody>
-</p:sp><p:sp>
-  <p:nvSpPr><p:cNvPr id="0" name="TB"/><p:cNvSpPr txBox="1"/><p:nvPr/></p:nvSpPr>
-  <p:spPr>
-    <a:xfrm><a:off x="7315200" y="5568696"/><a:ext cx="3840480" cy="384048"/></a:xfrm>
-    <a:prstGeom prst="rect"><a:avLst/></a:prstGeom><a:noFill/>
-  </p:spPr>
-  <p:txBody><a:bodyPr wrap="square" rtlCol="0"/><a:lstStyle/><a:p><a:pPr algn="l"/><a:r><a:rPr lang="en-US" sz="1100" b="1" dirty="0"><a:solidFill><a:srgbClr val="E0A458"/></a:solidFill><a:latin typeface="Calibri"/></a:rPr><a:t>Uttarakhand</a:t></a:r></a:p></p:txBody>
-</p:sp><p:sp>
-  <p:nvSpPr><p:cNvPr id="0" name="TB"/><p:cNvSpPr txBox="1"/><p:nvPr/></p:nvSpPr>
-  <p:spPr>
-    <a:xfrm><a:off x="640080" y="6126480"/><a:ext cx="10698480" cy="365760"/></a:xfrm>
-    <a:prstGeom prst="rect"><a:avLst/></a:prstGeom><a:noFill/>
-  </p:spPr>
-  <p:txBody><a:bodyPr wrap="square" rtlCol="0"/><a:lstStyle/><a:p><a:pPr algn="ctr"/><a:r><a:rPr lang="en-US" sz="1200" dirty="0"><a:solidFill><a:srgbClr val="3F7D58"/></a:solidFill><a:latin typeface="Calibri"/></a:rPr><a:t>Ye sab recent 6 months ke facts hain — Lower PCS mein bhi expect karo!</a:t></a:r></a:p></p:txBody>
-</p:sp>
+        <p:nvSpPr>
+          <p:cNvPr id="0" name="TB"/>
+          <p:cNvSpPr txBox="1"/>
+          <p:nvPr/>
+        </p:nvSpPr>
+        <p:spPr>
+          <a:xfrm>
+            <a:off x="640080" y="274320"/>
+            <a:ext cx="10972800" cy="548640"/>
+          </a:xfrm>
+          <a:prstGeom prst="rect">
+            <a:avLst/>
+          </a:prstGeom>
+          <a:noFill/>
+        </p:spPr>
+        <p:txBody>
+          <a:bodyPr wrap="square" rtlCol="0"/>
+          <a:lstStyle/>
+          <a:p>
+            <a:pPr algn="l"/>
+            <a:r>
+              <a:rPr lang="en-US" sz="2500" b="1" dirty="0">
+                <a:solidFill>
+                  <a:srgbClr val="FFFFFF"/>
+                </a:solidFill>
+                <a:latin typeface="Calibri"/>
+              </a:rPr>
+              <a:t>Current Affairs — Answer Key Highlights</a:t>
+            </a:r>
+          </a:p>
+        </p:txBody>
+      </p:sp>
+      <p:sp>
+        <p:nvSpPr>
+          <p:cNvPr id="0" name="TB"/>
+          <p:cNvSpPr txBox="1"/>
+          <p:nvPr/>
+        </p:nvSpPr>
+        <p:spPr>
+          <a:xfrm>
+            <a:off x="640080" y="731520"/>
+            <a:ext cx="10972800" cy="365760"/>
+          </a:xfrm>
+          <a:prstGeom prst="rect">
+            <a:avLst/>
+          </a:prstGeom>
+          <a:noFill/>
+        </p:spPr>
+        <p:txBody>
+          <a:bodyPr wrap="square" rtlCol="0"/>
+          <a:lstStyle/>
+          <a:p>
+            <a:pPr algn="l"/>
+            <a:r>
+              <a:rPr lang="en-US" sz="1300" dirty="0">
+                <a:solidFill>
+                  <a:srgbClr val="C7CFDB"/>
+                </a:solidFill>
+                <a:latin typeface="Calibri"/>
+              </a:rPr>
+              <a:t>Q177-Q195: National &amp; International Current Affairs</a:t>
+            </a:r>
+          </a:p>
+        </p:txBody>
+      </p:sp>
+      <p:sp>
+        <p:nvSpPr>
+          <p:cNvPr id="0" name="CH"/>
+          <p:cNvSpPr/>
+          <p:nvPr/>
+        </p:nvSpPr>
+        <p:spPr>
+          <a:xfrm>
+            <a:off x="640080" y="1188720"/>
+            <a:ext cx="10698480" cy="457200"/>
+          </a:xfrm>
+          <a:prstGeom prst="roundRect">
+            <a:avLst>
+              <a:gd name="adj" fmla="val 5000"/>
+            </a:avLst>
+          </a:prstGeom>
+          <a:solidFill>
+            <a:srgbClr val="2E4057"/>
+          </a:solidFill>
+          <a:ln>
+            <a:noFill/>
+          </a:ln>
+        </p:spPr>
+        <p:txBody>
+          <a:bodyPr/>
+          <a:lstStyle/>
+          <a:p>
+            <a:endParaRPr lang="en-US"/>
+          </a:p>
+        </p:txBody>
+      </p:sp>
+      <p:sp>
+        <p:nvSpPr>
+          <p:cNvPr id="0" name="TB"/>
+          <p:cNvSpPr txBox="1"/>
+          <p:nvPr/>
+        </p:nvSpPr>
+        <p:spPr>
+          <a:xfrm>
+            <a:off x="822960" y="1216152"/>
+            <a:ext cx="1371600" cy="411480"/>
+          </a:xfrm>
+          <a:prstGeom prst="rect">
+            <a:avLst/>
+          </a:prstGeom>
+          <a:noFill/>
+        </p:spPr>
+        <p:txBody>
+          <a:bodyPr wrap="square" rtlCol="0"/>
+          <a:lstStyle/>
+          <a:p>
+            <a:pPr algn="l"/>
+            <a:r>
+              <a:rPr lang="en-US" sz="1100" b="1" dirty="0">
+                <a:solidFill>
+                  <a:srgbClr val="FFFFFF"/>
+                </a:solidFill>
+                <a:latin typeface="Calibri"/>
+              </a:rPr>
+              <a:t>Q#</a:t>
+            </a:r>
+          </a:p>
+        </p:txBody>
+      </p:sp>
+      <p:sp>
+        <p:nvSpPr>
+          <p:cNvPr id="0" name="TB"/>
+          <p:cNvSpPr txBox="1"/>
+          <p:nvPr/>
+        </p:nvSpPr>
+        <p:spPr>
+          <a:xfrm>
+            <a:off x="2286000" y="1216152"/>
+            <a:ext cx="4572000" cy="411480"/>
+          </a:xfrm>
+          <a:prstGeom prst="rect">
+            <a:avLst/>
+          </a:prstGeom>
+          <a:noFill/>
+        </p:spPr>
+        <p:txBody>
+          <a:bodyPr wrap="square" rtlCol="0"/>
+          <a:lstStyle/>
+          <a:p>
+            <a:pPr algn="l"/>
+            <a:r>
+              <a:rPr lang="en-US" sz="1100" b="1" dirty="0">
+                <a:solidFill>
+                  <a:srgbClr val="FFFFFF"/>
+                </a:solidFill>
+                <a:latin typeface="Calibri"/>
+              </a:rPr>
+              <a:t>Topic</a:t>
+            </a:r>
+          </a:p>
+        </p:txBody>
+      </p:sp>
+      <p:sp>
+        <p:nvSpPr>
+          <p:cNvPr id="0" name="TB"/>
+          <p:cNvSpPr txBox="1"/>
+          <p:nvPr/>
+        </p:nvSpPr>
+        <p:spPr>
+          <a:xfrm>
+            <a:off x="7315200" y="1216152"/>
+            <a:ext cx="3840480" cy="411480"/>
+          </a:xfrm>
+          <a:prstGeom prst="rect">
+            <a:avLst/>
+          </a:prstGeom>
+          <a:noFill/>
+        </p:spPr>
+        <p:txBody>
+          <a:bodyPr wrap="square" rtlCol="0"/>
+          <a:lstStyle/>
+          <a:p>
+            <a:pPr algn="l"/>
+            <a:r>
+              <a:rPr lang="en-US" sz="1100" b="1" dirty="0">
+                <a:solidFill>
+                  <a:srgbClr val="E0A458"/>
+                </a:solidFill>
+                <a:latin typeface="Calibri"/>
+              </a:rPr>
+              <a:t>Answer</a:t>
+            </a:r>
+          </a:p>
+        </p:txBody>
+      </p:sp>
+      <p:sp>
+        <p:nvSpPr>
+          <p:cNvPr id="0" name="CA0"/>
+          <p:cNvSpPr/>
+          <p:nvPr/>
+        </p:nvSpPr>
+        <p:spPr>
+          <a:xfrm>
+            <a:off x="640080" y="1737360"/>
+            <a:ext cx="10698480" cy="438912"/>
+          </a:xfrm>
+          <a:prstGeom prst="roundRect">
+            <a:avLst>
+              <a:gd name="adj" fmla="val 5000"/>
+            </a:avLst>
+          </a:prstGeom>
+          <a:solidFill>
+            <a:srgbClr val="16233A"/>
+          </a:solidFill>
+          <a:ln>
+            <a:noFill/>
+          </a:ln>
+        </p:spPr>
+        <p:txBody>
+          <a:bodyPr/>
+          <a:lstStyle/>
+          <a:p>
+            <a:endParaRPr lang="en-US"/>
+          </a:p>
+        </p:txBody>
+      </p:sp>
+      <p:sp>
+        <p:nvSpPr>
+          <p:cNvPr id="0" name="TB"/>
+          <p:cNvSpPr txBox="1"/>
+          <p:nvPr/>
+        </p:nvSpPr>
+        <p:spPr>
+          <a:xfrm>
+            <a:off x="822960" y="1764792"/>
+            <a:ext cx="1371600" cy="384048"/>
+          </a:xfrm>
+          <a:prstGeom prst="rect">
+            <a:avLst/>
+          </a:prstGeom>
+          <a:noFill/>
+        </p:spPr>
+        <p:txBody>
+          <a:bodyPr wrap="square" rtlCol="0"/>
+          <a:lstStyle/>
+          <a:p>
+            <a:pPr algn="l"/>
+            <a:r>
+              <a:rPr lang="en-US" sz="1100" dirty="0">
+                <a:solidFill>
+                  <a:srgbClr val="C7CFDB"/>
+                </a:solidFill>
+                <a:latin typeface="Calibri"/>
+              </a:rPr>
+              <a:t>Q178</a:t>
+            </a:r>
+          </a:p>
+        </p:txBody>
+      </p:sp>
+      <p:sp>
+        <p:nvSpPr>
+          <p:cNvPr id="0" name="TB"/>
+          <p:cNvSpPr txBox="1"/>
+          <p:nvPr/>
+        </p:nvSpPr>
+        <p:spPr>
+          <a:xfrm>
+            <a:off x="2286000" y="1764792"/>
+            <a:ext cx="4572000" cy="384048"/>
+          </a:xfrm>
+          <a:prstGeom prst="rect">
+            <a:avLst/>
+          </a:prstGeom>
+          <a:noFill/>
+        </p:spPr>
+        <p:txBody>
+          <a:bodyPr wrap="square" rtlCol="0"/>
+          <a:lstStyle/>
+          <a:p>
+            <a:pPr algn="l"/>
+            <a:r>
+              <a:rPr lang="en-US" sz="1100" dirty="0">
+                <a:solidFill>
+                  <a:srgbClr val="FFFFFF"/>
+                </a:solidFill>
+                <a:latin typeface="Calibri"/>
+              </a:rPr>
+              <a:t>WEF Davos 2026 Theme</a:t>
+            </a:r>
+          </a:p>
+        </p:txBody>
+      </p:sp>
+      <p:sp>
+        <p:nvSpPr>
+          <p:cNvPr id="0" name="TB"/>
+          <p:cNvSpPr txBox="1"/>
+          <p:nvPr/>
+        </p:nvSpPr>
+        <p:spPr>
+          <a:xfrm>
+            <a:off x="7315200" y="1764792"/>
+            <a:ext cx="3840480" cy="384048"/>
+          </a:xfrm>
+          <a:prstGeom prst="rect">
+            <a:avLst/>
+          </a:prstGeom>
+          <a:noFill/>
+        </p:spPr>
+        <p:txBody>
+          <a:bodyPr wrap="square" rtlCol="0"/>
+          <a:lstStyle/>
+          <a:p>
+            <a:pPr algn="l"/>
+            <a:r>
+              <a:rPr lang="en-US" sz="1100" b="1" dirty="0">
+                <a:solidFill>
+                  <a:srgbClr val="E0A458"/>
+                </a:solidFill>
+                <a:latin typeface="Calibri"/>
+              </a:rPr>
+              <a:t>Cooperation in a Fragmented World</a:t>
+            </a:r>
+          </a:p>
+        </p:txBody>
+      </p:sp>
+      <p:sp>
+        <p:nvSpPr>
+          <p:cNvPr id="0" name="CA1"/>
+          <p:cNvSpPr/>
+          <p:nvPr/>
+        </p:nvSpPr>
+        <p:spPr>
+          <a:xfrm>
+            <a:off x="640080" y="2212848"/>
+            <a:ext cx="10698480" cy="438912"/>
+          </a:xfrm>
+          <a:prstGeom prst="roundRect">
+            <a:avLst>
+              <a:gd name="adj" fmla="val 5000"/>
+            </a:avLst>
+          </a:prstGeom>
+          <a:solidFill>
+            <a:srgbClr val="2E4057"/>
+          </a:solidFill>
+          <a:ln>
+            <a:noFill/>
+          </a:ln>
+        </p:spPr>
+        <p:txBody>
+          <a:bodyPr/>
+          <a:lstStyle/>
+          <a:p>
+            <a:endParaRPr lang="en-US"/>
+          </a:p>
+        </p:txBody>
+      </p:sp>
+      <p:sp>
+        <p:nvSpPr>
+          <p:cNvPr id="0" name="TB"/>
+          <p:cNvSpPr txBox="1"/>
+          <p:nvPr/>
+        </p:nvSpPr>
+        <p:spPr>
+          <a:xfrm>
+            <a:off x="822960" y="2240280"/>
+            <a:ext cx="1371600" cy="384048"/>
+          </a:xfrm>
+          <a:prstGeom prst="rect">
+            <a:avLst/>
+          </a:prstGeom>
+          <a:noFill/>
+        </p:spPr>
+        <p:txBody>
+          <a:bodyPr wrap="square" rtlCol="0"/>
+          <a:lstStyle/>
+          <a:p>
+            <a:pPr algn="l"/>
+            <a:r>
+              <a:rPr lang="en-US" sz="1100" dirty="0">
+                <a:solidFill>
+                  <a:srgbClr val="C7CFDB"/>
+                </a:solidFill>
+                <a:latin typeface="Calibri"/>
+              </a:rPr>
+              <a:t>Q179</a:t>
+            </a:r>
+          </a:p>
+        </p:txBody>
+      </p:sp>
+      <p:sp>
+        <p:nvSpPr>
+          <p:cNvPr id="0" name="TB"/>
+          <p:cNvSpPr txBox="1"/>
+          <p:nvPr/>
+        </p:nvSpPr>
+        <p:spPr>
+          <a:xfrm>
+            <a:off x="2286000" y="2240280"/>
+            <a:ext cx="4572000" cy="384048"/>
+          </a:xfrm>
+          <a:prstGeom prst="rect">
+            <a:avLst/>
+          </a:prstGeom>
+          <a:noFill/>
+        </p:spPr>
+        <p:txBody>
+          <a:bodyPr wrap="square" rtlCol="0"/>
+          <a:lstStyle/>
+          <a:p>
+            <a:pPr algn="l"/>
+            <a:r>
+              <a:rPr lang="en-US" sz="1100" dirty="0">
+                <a:solidFill>
+                  <a:srgbClr val="FFFFFF"/>
+                </a:solidFill>
+                <a:latin typeface="Calibri"/>
+              </a:rPr>
+              <a:t>EU Council President</a:t>
+            </a:r>
+          </a:p>
+        </p:txBody>
+      </p:sp>
+      <p:sp>
+        <p:nvSpPr>
+          <p:cNvPr id="0" name="TB"/>
+          <p:cNvSpPr txBox="1"/>
+          <p:nvPr/>
+        </p:nvSpPr>
+        <p:spPr>
+          <a:xfrm>
+            <a:off x="7315200" y="2240280"/>
+            <a:ext cx="3840480" cy="384048"/>
+          </a:xfrm>
+          <a:prstGeom prst="rect">
+            <a:avLst/>
+          </a:prstGeom>
+          <a:noFill/>
+        </p:spPr>
+        <p:txBody>
+          <a:bodyPr wrap="square" rtlCol="0"/>
+          <a:lstStyle/>
+          <a:p>
+            <a:pPr algn="l"/>
+            <a:r>
+              <a:rPr lang="en-US" sz="1100" b="1" dirty="0">
+                <a:solidFill>
+                  <a:srgbClr val="E0A458"/>
+                </a:solidFill>
+                <a:latin typeface="Calibri"/>
+              </a:rPr>
+              <a:t>Antonio Costa</a:t>
+            </a:r>
+          </a:p>
+        </p:txBody>
+      </p:sp>
+      <p:sp>
+        <p:nvSpPr>
+          <p:cNvPr id="0" name="CA2"/>
+          <p:cNvSpPr/>
+          <p:nvPr/>
+        </p:nvSpPr>
+        <p:spPr>
+          <a:xfrm>
+            <a:off x="640080" y="2688336"/>
+            <a:ext cx="10698480" cy="438912"/>
+          </a:xfrm>
+          <a:prstGeom prst="roundRect">
+            <a:avLst>
+              <a:gd name="adj" fmla="val 5000"/>
+            </a:avLst>
+          </a:prstGeom>
+          <a:solidFill>
+            <a:srgbClr val="16233A"/>
+          </a:solidFill>
+          <a:ln>
+            <a:noFill/>
+          </a:ln>
+        </p:spPr>
+        <p:txBody>
+          <a:bodyPr/>
+          <a:lstStyle/>
+          <a:p>
+            <a:endParaRPr lang="en-US"/>
+          </a:p>
+        </p:txBody>
+      </p:sp>
+      <p:sp>
+        <p:nvSpPr>
+          <p:cNvPr id="0" name="TB"/>
+          <p:cNvSpPr txBox="1"/>
+          <p:nvPr/>
+        </p:nvSpPr>
+        <p:spPr>
+          <a:xfrm>
+            <a:off x="822960" y="2715768"/>
+            <a:ext cx="1371600" cy="384048"/>
+          </a:xfrm>
+          <a:prstGeom prst="rect">
+            <a:avLst/>
+          </a:prstGeom>
+          <a:noFill/>
+        </p:spPr>
+        <p:txBody>
+          <a:bodyPr wrap="square" rtlCol="0"/>
+          <a:lstStyle/>
+          <a:p>
+            <a:pPr algn="l"/>
+            <a:r>
+              <a:rPr lang="en-US" sz="1100" dirty="0">
+                <a:solidFill>
+                  <a:srgbClr val="C7CFDB"/>
+                </a:solidFill>
+                <a:latin typeface="Calibri"/>
+              </a:rPr>
+              <a:t>Q181</a:t>
+            </a:r>
+          </a:p>
+        </p:txBody>
+      </p:sp>
+      <p:sp>
+        <p:nvSpPr>
+          <p:cNvPr id="0" name="TB"/>
+          <p:cNvSpPr txBox="1"/>
+          <p:nvPr/>
+        </p:nvSpPr>
+        <p:spPr>
+          <a:xfrm>
+            <a:off x="2286000" y="2715768"/>
+            <a:ext cx="4572000" cy="384048"/>
+          </a:xfrm>
+          <a:prstGeom prst="rect">
+            <a:avLst/>
+          </a:prstGeom>
+          <a:noFill/>
+        </p:spPr>
+        <p:txBody>
+          <a:bodyPr wrap="square" rtlCol="0"/>
+          <a:lstStyle/>
+          <a:p>
+            <a:pPr algn="l"/>
+            <a:r>
+              <a:rPr lang="en-US" sz="1100" dirty="0">
+                <a:solidFill>
+                  <a:srgbClr val="FFFFFF"/>
+                </a:solidFill>
+                <a:latin typeface="Calibri"/>
+              </a:rPr>
+              <a:t>Nobel Peace Prize 2025</a:t>
+            </a:r>
+          </a:p>
+        </p:txBody>
+      </p:sp>
+      <p:sp>
+        <p:nvSpPr>
+          <p:cNvPr id="0" name="TB"/>
+          <p:cNvSpPr txBox="1"/>
+          <p:nvPr/>
+        </p:nvSpPr>
+        <p:spPr>
+          <a:xfrm>
+            <a:off x="7315200" y="2715768"/>
+            <a:ext cx="3840480" cy="384048"/>
+          </a:xfrm>
+          <a:prstGeom prst="rect">
+            <a:avLst/>
+          </a:prstGeom>
+          <a:noFill/>
+        </p:spPr>
+        <p:txBody>
+          <a:bodyPr wrap="square" rtlCol="0"/>
+          <a:lstStyle/>
+          <a:p>
+            <a:pPr algn="l"/>
+            <a:r>
+              <a:rPr lang="en-US" sz="1100" b="1" dirty="0">
+                <a:solidFill>
+                  <a:srgbClr val="E0A458"/>
+                </a:solidFill>
+                <a:latin typeface="Calibri"/>
+              </a:rPr>
+              <a:t>Nihon Hidankyo</a:t>
+            </a:r>
+          </a:p>
+        </p:txBody>
+      </p:sp>
+      <p:sp>
+        <p:nvSpPr>
+          <p:cNvPr id="0" name="CA3"/>
+          <p:cNvSpPr/>
+          <p:nvPr/>
+        </p:nvSpPr>
+        <p:spPr>
+          <a:xfrm>
+            <a:off x="640080" y="3163824"/>
+            <a:ext cx="10698480" cy="438912"/>
+          </a:xfrm>
+          <a:prstGeom prst="roundRect">
+            <a:avLst>
+              <a:gd name="adj" fmla="val 5000"/>
+            </a:avLst>
+          </a:prstGeom>
+          <a:solidFill>
+            <a:srgbClr val="2E4057"/>
+          </a:solidFill>
+          <a:ln>
+            <a:noFill/>
+          </a:ln>
+        </p:spPr>
+        <p:txBody>
+          <a:bodyPr/>
+          <a:lstStyle/>
+          <a:p>
+            <a:endParaRPr lang="en-US"/>
+          </a:p>
+        </p:txBody>
+      </p:sp>
+      <p:sp>
+        <p:nvSpPr>
+          <p:cNvPr id="0" name="TB"/>
+          <p:cNvSpPr txBox="1"/>
+          <p:nvPr/>
+        </p:nvSpPr>
+        <p:spPr>
+          <a:xfrm>
+            <a:off x="822960" y="3191256"/>
+            <a:ext cx="1371600" cy="384048"/>
+          </a:xfrm>
+          <a:prstGeom prst="rect">
+            <a:avLst/>
+          </a:prstGeom>
+          <a:noFill/>
+        </p:spPr>
+        <p:txBody>
+          <a:bodyPr wrap="square" rtlCol="0"/>
+          <a:lstStyle/>
+          <a:p>
+            <a:pPr algn="l"/>
+            <a:r>
+              <a:rPr lang="en-US" sz="1100" dirty="0">
+                <a:solidFill>
+                  <a:srgbClr val="C7CFDB"/>
+                </a:solidFill>
+                <a:latin typeface="Calibri"/>
+              </a:rPr>
+              <a:t>Q183</a:t>
+            </a:r>
+          </a:p>
+        </p:txBody>
+      </p:sp>
+      <p:sp>
+        <p:nvSpPr>
+          <p:cNvPr id="0" name="TB"/>
+          <p:cNvSpPr txBox="1"/>
+          <p:nvPr/>
+        </p:nvSpPr>
+        <p:spPr>
+          <a:xfrm>
+            <a:off x="2286000" y="3191256"/>
+            <a:ext cx="4572000" cy="384048"/>
+          </a:xfrm>
+          <a:prstGeom prst="rect">
+            <a:avLst/>
+          </a:prstGeom>
+          <a:noFill/>
+        </p:spPr>
+        <p:txBody>
+          <a:bodyPr wrap="square" rtlCol="0"/>
+          <a:lstStyle/>
+          <a:p>
+            <a:pPr algn="l"/>
+            <a:r>
+              <a:rPr lang="en-US" sz="1100" dirty="0">
+                <a:solidFill>
+                  <a:srgbClr val="FFFFFF"/>
+                </a:solidFill>
+                <a:latin typeface="Calibri"/>
+              </a:rPr>
+              <a:t>IOAA 2026 Host</a:t>
+            </a:r>
+          </a:p>
+        </p:txBody>
+      </p:sp>
+      <p:sp>
+        <p:nvSpPr>
+          <p:cNvPr id="0" name="TB"/>
+          <p:cNvSpPr txBox="1"/>
+          <p:nvPr/>
+        </p:nvSpPr>
+        <p:spPr>
+          <a:xfrm>
+            <a:off x="7315200" y="3191256"/>
+            <a:ext cx="3840480" cy="384048"/>
+          </a:xfrm>
+          <a:prstGeom prst="rect">
+            <a:avLst/>
+          </a:prstGeom>
+          <a:noFill/>
+        </p:spPr>
+        <p:txBody>
+          <a:bodyPr wrap="square" rtlCol="0"/>
+          <a:lstStyle/>
+          <a:p>
+            <a:pPr algn="l"/>
+            <a:r>
+              <a:rPr lang="en-US" sz="1100" b="1" dirty="0">
+                <a:solidFill>
+                  <a:srgbClr val="E0A458"/>
+                </a:solidFill>
+                <a:latin typeface="Calibri"/>
+              </a:rPr>
+              <a:t>Mumbai, India</a:t>
+            </a:r>
+          </a:p>
+        </p:txBody>
+      </p:sp>
+      <p:sp>
+        <p:nvSpPr>
+          <p:cNvPr id="0" name="CA4"/>
+          <p:cNvSpPr/>
+          <p:nvPr/>
+        </p:nvSpPr>
+        <p:spPr>
+          <a:xfrm>
+            <a:off x="640080" y="3639312"/>
+            <a:ext cx="10698480" cy="438912"/>
+          </a:xfrm>
+          <a:prstGeom prst="roundRect">
+            <a:avLst>
+              <a:gd name="adj" fmla="val 5000"/>
+            </a:avLst>
+          </a:prstGeom>
+          <a:solidFill>
+            <a:srgbClr val="16233A"/>
+          </a:solidFill>
+          <a:ln>
+            <a:noFill/>
+          </a:ln>
+        </p:spPr>
+        <p:txBody>
+          <a:bodyPr/>
+          <a:lstStyle/>
+          <a:p>
+            <a:endParaRPr lang="en-US"/>
+          </a:p>
+        </p:txBody>
+      </p:sp>
+      <p:sp>
+        <p:nvSpPr>
+          <p:cNvPr id="0" name="TB"/>
+          <p:cNvSpPr txBox="1"/>
+          <p:nvPr/>
+        </p:nvSpPr>
+        <p:spPr>
+          <a:xfrm>
+            <a:off x="822960" y="3666744"/>
+            <a:ext cx="1371600" cy="384048"/>
+          </a:xfrm>
+          <a:prstGeom prst="rect">
+            <a:avLst/>
+          </a:prstGeom>
+          <a:noFill/>
+        </p:spPr>
+        <p:txBody>
+          <a:bodyPr wrap="square" rtlCol="0"/>
+          <a:lstStyle/>
+          <a:p>
+            <a:pPr algn="l"/>
+            <a:r>
+              <a:rPr lang="en-US" sz="1100" dirty="0">
+                <a:solidFill>
+                  <a:srgbClr val="C7CFDB"/>
+                </a:solidFill>
+                <a:latin typeface="Calibri"/>
+              </a:rPr>
+              <a:t>Q184</a:t>
+            </a:r>
+          </a:p>
+        </p:txBody>
+      </p:sp>
+      <p:sp>
+        <p:nvSpPr>
+          <p:cNvPr id="0" name="TB"/>
+          <p:cNvSpPr txBox="1"/>
+          <p:nvPr/>
+        </p:nvSpPr>
+        <p:spPr>
+          <a:xfrm>
+            <a:off x="2286000" y="3666744"/>
+            <a:ext cx="4572000" cy="384048"/>
+          </a:xfrm>
+          <a:prstGeom prst="rect">
+            <a:avLst/>
+          </a:prstGeom>
+          <a:noFill/>
+        </p:spPr>
+        <p:txBody>
+          <a:bodyPr wrap="square" rtlCol="0"/>
+          <a:lstStyle/>
+          <a:p>
+            <a:pPr algn="l"/>
+            <a:r>
+              <a:rPr lang="en-US" sz="1100" dirty="0">
+                <a:solidFill>
+                  <a:srgbClr val="FFFFFF"/>
+                </a:solidFill>
+                <a:latin typeface="Calibri"/>
+              </a:rPr>
+              <a:t>Sri Lanka PM</a:t>
+            </a:r>
+          </a:p>
+        </p:txBody>
+      </p:sp>
+      <p:sp>
+        <p:nvSpPr>
+          <p:cNvPr id="0" name="TB"/>
+          <p:cNvSpPr txBox="1"/>
+          <p:nvPr/>
+        </p:nvSpPr>
+        <p:spPr>
+          <a:xfrm>
+            <a:off x="7315200" y="3666744"/>
+            <a:ext cx="3840480" cy="384048"/>
+          </a:xfrm>
+          <a:prstGeom prst="rect">
+            <a:avLst/>
+          </a:prstGeom>
+          <a:noFill/>
+        </p:spPr>
+        <p:txBody>
+          <a:bodyPr wrap="square" rtlCol="0"/>
+          <a:lstStyle/>
+          <a:p>
+            <a:pPr algn="l"/>
+            <a:r>
+              <a:rPr lang="en-US" sz="1100" b="1" dirty="0">
+                <a:solidFill>
+                  <a:srgbClr val="E0A458"/>
+                </a:solidFill>
+                <a:latin typeface="Calibri"/>
+              </a:rPr>
+              <a:t>Harini Amarasuriya</a:t>
+            </a:r>
+          </a:p>
+        </p:txBody>
+      </p:sp>
+      <p:sp>
+        <p:nvSpPr>
+          <p:cNvPr id="0" name="CA5"/>
+          <p:cNvSpPr/>
+          <p:nvPr/>
+        </p:nvSpPr>
+        <p:spPr>
+          <a:xfrm>
+            <a:off x="640080" y="4114800"/>
+            <a:ext cx="10698480" cy="438912"/>
+          </a:xfrm>
+          <a:prstGeom prst="roundRect">
+            <a:avLst>
+              <a:gd name="adj" fmla="val 5000"/>
+            </a:avLst>
+          </a:prstGeom>
+          <a:solidFill>
+            <a:srgbClr val="2E4057"/>
+          </a:solidFill>
+          <a:ln>
+            <a:noFill/>
+          </a:ln>
+        </p:spPr>
+        <p:txBody>
+          <a:bodyPr/>
+          <a:lstStyle/>
+          <a:p>
+            <a:endParaRPr lang="en-US"/>
+          </a:p>
+        </p:txBody>
+      </p:sp>
+      <p:sp>
+        <p:nvSpPr>
+          <p:cNvPr id="0" name="TB"/>
+          <p:cNvSpPr txBox="1"/>
+          <p:nvPr/>
+        </p:nvSpPr>
+        <p:spPr>
+          <a:xfrm>
+            <a:off x="822960" y="4142232"/>
+            <a:ext cx="1371600" cy="384048"/>
+          </a:xfrm>
+          <a:prstGeom prst="rect">
+            <a:avLst/>
+          </a:prstGeom>
+          <a:noFill/>
+        </p:spPr>
+        <p:txBody>
+          <a:bodyPr wrap="square" rtlCol="0"/>
+          <a:lstStyle/>
+          <a:p>
+            <a:pPr algn="l"/>
+            <a:r>
+              <a:rPr lang="en-US" sz="1100" dirty="0">
+                <a:solidFill>
+                  <a:srgbClr val="C7CFDB"/>
+                </a:solidFill>
+                <a:latin typeface="Calibri"/>
+              </a:rPr>
+              <a:t>Q186</a:t>
+            </a:r>
+          </a:p>
+        </p:txBody>
+      </p:sp>
+      <p:sp>
+        <p:nvSpPr>
+          <p:cNvPr id="0" name="TB"/>
+          <p:cNvSpPr txBox="1"/>
+          <p:nvPr/>
+        </p:nvSpPr>
+        <p:spPr>
+          <a:xfrm>
+            <a:off x="2286000" y="4142232"/>
+            <a:ext cx="4572000" cy="384048"/>
+          </a:xfrm>
+          <a:prstGeom prst="rect">
+            <a:avLst/>
+          </a:prstGeom>
+          <a:noFill/>
+        </p:spPr>
+        <p:txBody>
+          <a:bodyPr wrap="square" rtlCol="0"/>
+          <a:lstStyle/>
+          <a:p>
+            <a:pPr algn="l"/>
+            <a:r>
+              <a:rPr lang="en-US" sz="1100" dirty="0">
+                <a:solidFill>
+                  <a:srgbClr val="FFFFFF"/>
+                </a:solidFill>
+                <a:latin typeface="Calibri"/>
+              </a:rPr>
+              <a:t>IWD 2026 Theme</a:t>
+            </a:r>
+          </a:p>
+        </p:txBody>
+      </p:sp>
+      <p:sp>
+        <p:nvSpPr>
+          <p:cNvPr id="0" name="TB"/>
+          <p:cNvSpPr txBox="1"/>
+          <p:nvPr/>
+        </p:nvSpPr>
+        <p:spPr>
+          <a:xfrm>
+            <a:off x="7315200" y="4142232"/>
+            <a:ext cx="3840480" cy="384048"/>
+          </a:xfrm>
+          <a:prstGeom prst="rect">
+            <a:avLst/>
+          </a:prstGeom>
+          <a:noFill/>
+        </p:spPr>
+        <p:txBody>
+          <a:bodyPr wrap="square" rtlCol="0"/>
+          <a:lstStyle/>
+          <a:p>
+            <a:pPr algn="l"/>
+            <a:r>
+              <a:rPr lang="en-US" sz="1100" b="1" dirty="0">
+                <a:solidFill>
+                  <a:srgbClr val="E0A458"/>
+                </a:solidFill>
+                <a:latin typeface="Calibri"/>
+              </a:rPr>
+              <a:t>Rights, Justice &amp; Action</a:t>
+            </a:r>
+          </a:p>
+        </p:txBody>
+      </p:sp>
+      <p:sp>
+        <p:nvSpPr>
+          <p:cNvPr id="0" name="CA6"/>
+          <p:cNvSpPr/>
+          <p:nvPr/>
+        </p:nvSpPr>
+        <p:spPr>
+          <a:xfrm>
+            <a:off x="640080" y="4590288"/>
+            <a:ext cx="10698480" cy="438912"/>
+          </a:xfrm>
+          <a:prstGeom prst="roundRect">
+            <a:avLst>
+              <a:gd name="adj" fmla="val 5000"/>
+            </a:avLst>
+          </a:prstGeom>
+          <a:solidFill>
+            <a:srgbClr val="16233A"/>
+          </a:solidFill>
+          <a:ln>
+            <a:noFill/>
+          </a:ln>
+        </p:spPr>
+        <p:txBody>
+          <a:bodyPr/>
+          <a:lstStyle/>
+          <a:p>
+            <a:endParaRPr lang="en-US"/>
+          </a:p>
+        </p:txBody>
+      </p:sp>
+      <p:sp>
+        <p:nvSpPr>
+          <p:cNvPr id="0" name="TB"/>
+          <p:cNvSpPr txBox="1"/>
+          <p:nvPr/>
+        </p:nvSpPr>
+        <p:spPr>
+          <a:xfrm>
+            <a:off x="822960" y="4617720"/>
+            <a:ext cx="1371600" cy="384048"/>
+          </a:xfrm>
+          <a:prstGeom prst="rect">
+            <a:avLst/>
+          </a:prstGeom>
+          <a:noFill/>
+        </p:spPr>
+        <p:txBody>
+          <a:bodyPr wrap="square" rtlCol="0"/>
+          <a:lstStyle/>
+          <a:p>
+            <a:pPr algn="l"/>
+            <a:r>
+              <a:rPr lang="en-US" sz="1100" dirty="0">
+                <a:solidFill>
+                  <a:srgbClr val="C7CFDB"/>
+                </a:solidFill>
+                <a:latin typeface="Calibri"/>
+              </a:rPr>
+              <a:t>Q189</a:t>
+            </a:r>
+          </a:p>
+        </p:txBody>
+      </p:sp>
+      <p:sp>
+        <p:nvSpPr>
+          <p:cNvPr id="0" name="TB"/>
+          <p:cNvSpPr txBox="1"/>
+          <p:nvPr/>
+        </p:nvSpPr>
+        <p:spPr>
+          <a:xfrm>
+            <a:off x="2286000" y="4617720"/>
+            <a:ext cx="4572000" cy="384048"/>
+          </a:xfrm>
+          <a:prstGeom prst="rect">
+            <a:avLst/>
+          </a:prstGeom>
+          <a:noFill/>
+        </p:spPr>
+        <p:txBody>
+          <a:bodyPr wrap="square" rtlCol="0"/>
+          <a:lstStyle/>
+          <a:p>
+            <a:pPr algn="l"/>
+            <a:r>
+              <a:rPr lang="en-US" sz="1100" dirty="0">
+                <a:solidFill>
+                  <a:srgbClr val="FFFFFF"/>
+                </a:solidFill>
+                <a:latin typeface="Calibri"/>
+              </a:rPr>
+              <a:t>1971 War Film (Jan 2026)</a:t>
+            </a:r>
+          </a:p>
+        </p:txBody>
+      </p:sp>
+      <p:sp>
+        <p:nvSpPr>
+          <p:cNvPr id="0" name="TB"/>
+          <p:cNvSpPr txBox="1"/>
+          <p:nvPr/>
+        </p:nvSpPr>
+        <p:spPr>
+          <a:xfrm>
+            <a:off x="7315200" y="4617720"/>
+            <a:ext cx="3840480" cy="384048"/>
+          </a:xfrm>
+          <a:prstGeom prst="rect">
+            <a:avLst/>
+          </a:prstGeom>
+          <a:noFill/>
+        </p:spPr>
+        <p:txBody>
+          <a:bodyPr wrap="square" rtlCol="0"/>
+          <a:lstStyle/>
+          <a:p>
+            <a:pPr algn="l"/>
+            <a:r>
+              <a:rPr lang="en-US" sz="1100" b="1" dirty="0">
+                <a:solidFill>
+                  <a:srgbClr val="E0A458"/>
+                </a:solidFill>
+                <a:latin typeface="Calibri"/>
+              </a:rPr>
+              <a:t>Ikkees (Arun Khetarpal)</a:t>
+            </a:r>
+          </a:p>
+        </p:txBody>
+      </p:sp>
+      <p:sp>
+        <p:nvSpPr>
+          <p:cNvPr id="0" name="CA7"/>
+          <p:cNvSpPr/>
+          <p:nvPr/>
+        </p:nvSpPr>
+        <p:spPr>
+          <a:xfrm>
+            <a:off x="640080" y="5065776"/>
+            <a:ext cx="10698480" cy="438912"/>
+          </a:xfrm>
+          <a:prstGeom prst="roundRect">
+            <a:avLst>
+              <a:gd name="adj" fmla="val 5000"/>
+            </a:avLst>
+          </a:prstGeom>
+          <a:solidFill>
+            <a:srgbClr val="2E4057"/>
+          </a:solidFill>
+          <a:ln>
+            <a:noFill/>
+          </a:ln>
+        </p:spPr>
+        <p:txBody>
+          <a:bodyPr/>
+          <a:lstStyle/>
+          <a:p>
+            <a:endParaRPr lang="en-US"/>
+          </a:p>
+        </p:txBody>
+      </p:sp>
+      <p:sp>
+        <p:nvSpPr>
+          <p:cNvPr id="0" name="TB"/>
+          <p:cNvSpPr txBox="1"/>
+          <p:nvPr/>
+        </p:nvSpPr>
+        <p:spPr>
+          <a:xfrm>
+            <a:off x="822960" y="5093208"/>
+            <a:ext cx="1371600" cy="384048"/>
+          </a:xfrm>
+          <a:prstGeom prst="rect">
+            <a:avLst/>
+          </a:prstGeom>
+          <a:noFill/>
+        </p:spPr>
+        <p:txBody>
+          <a:bodyPr wrap="square" rtlCol="0"/>
+          <a:lstStyle/>
+          <a:p>
+            <a:pPr algn="l"/>
+            <a:r>
+              <a:rPr lang="en-US" sz="1100" dirty="0">
+                <a:solidFill>
+                  <a:srgbClr val="C7CFDB"/>
+                </a:solidFill>
+                <a:latin typeface="Calibri"/>
+              </a:rPr>
+              <a:t>Q192</a:t>
+            </a:r>
+          </a:p>
+        </p:txBody>
+      </p:sp>
+      <p:sp>
+        <p:nvSpPr>
+          <p:cNvPr id="0" name="TB"/>
+          <p:cNvSpPr txBox="1"/>
+          <p:nvPr/>
+        </p:nvSpPr>
+        <p:spPr>
+          <a:xfrm>
+            <a:off x="2286000" y="5093208"/>
+            <a:ext cx="4572000" cy="384048"/>
+          </a:xfrm>
+          <a:prstGeom prst="rect">
+            <a:avLst/>
+          </a:prstGeom>
+          <a:noFill/>
+        </p:spPr>
+        <p:txBody>
+          <a:bodyPr wrap="square" rtlCol="0"/>
+          <a:lstStyle/>
+          <a:p>
+            <a:pPr algn="l"/>
+            <a:r>
+              <a:rPr lang="en-US" sz="1100" dirty="0">
+                <a:solidFill>
+                  <a:srgbClr val="FFFFFF"/>
+                </a:solidFill>
+                <a:latin typeface="Calibri"/>
+              </a:rPr>
+              <a:t>Indian Fighter Jet 25th Anniv.</a:t>
+            </a:r>
+          </a:p>
+        </p:txBody>
+      </p:sp>
+      <p:sp>
+        <p:nvSpPr>
+          <p:cNvPr id="0" name="TB"/>
+          <p:cNvSpPr txBox="1"/>
+          <p:nvPr/>
+        </p:nvSpPr>
+        <p:spPr>
+          <a:xfrm>
+            <a:off x="7315200" y="5093208"/>
+            <a:ext cx="3840480" cy="384048"/>
+          </a:xfrm>
+          <a:prstGeom prst="rect">
+            <a:avLst/>
+          </a:prstGeom>
+          <a:noFill/>
+        </p:spPr>
+        <p:txBody>
+          <a:bodyPr wrap="square" rtlCol="0"/>
+          <a:lstStyle/>
+          <a:p>
+            <a:pPr algn="l"/>
+            <a:r>
+              <a:rPr lang="en-US" sz="1100" b="1" dirty="0">
+                <a:solidFill>
+                  <a:srgbClr val="E0A458"/>
+                </a:solidFill>
+                <a:latin typeface="Calibri"/>
+              </a:rPr>
+              <a:t>Tejas</a:t>
+            </a:r>
+          </a:p>
+        </p:txBody>
+      </p:sp>
+      <p:sp>
+        <p:nvSpPr>
+          <p:cNvPr id="0" name="CA8"/>
+          <p:cNvSpPr/>
+          <p:nvPr/>
+        </p:nvSpPr>
+        <p:spPr>
+          <a:xfrm>
+            <a:off x="640080" y="5541264"/>
+            <a:ext cx="10698480" cy="438912"/>
+          </a:xfrm>
+          <a:prstGeom prst="roundRect">
+            <a:avLst>
+              <a:gd name="adj" fmla="val 5000"/>
+            </a:avLst>
+          </a:prstGeom>
+          <a:solidFill>
+            <a:srgbClr val="16233A"/>
+          </a:solidFill>
+          <a:ln>
+            <a:noFill/>
+          </a:ln>
+        </p:spPr>
+        <p:txBody>
+          <a:bodyPr/>
+          <a:lstStyle/>
+          <a:p>
+            <a:endParaRPr lang="en-US"/>
+          </a:p>
+        </p:txBody>
+      </p:sp>
+      <p:sp>
+        <p:nvSpPr>
+          <p:cNvPr id="0" name="TB"/>
+          <p:cNvSpPr txBox="1"/>
+          <p:nvPr/>
+        </p:nvSpPr>
+        <p:spPr>
+          <a:xfrm>
+            <a:off x="822960" y="5568696"/>
+            <a:ext cx="1371600" cy="384048"/>
+          </a:xfrm>
+          <a:prstGeom prst="rect">
+            <a:avLst/>
+          </a:prstGeom>
+          <a:noFill/>
+        </p:spPr>
+        <p:txBody>
+          <a:bodyPr wrap="square" rtlCol="0"/>
+          <a:lstStyle/>
+          <a:p>
+            <a:pPr algn="l"/>
+            <a:r>
+              <a:rPr lang="en-US" sz="1100" dirty="0">
+                <a:solidFill>
+                  <a:srgbClr val="C7CFDB"/>
+                </a:solidFill>
+                <a:latin typeface="Calibri"/>
+              </a:rPr>
+              <a:t>Q193</a:t>
+            </a:r>
+          </a:p>
+        </p:txBody>
+      </p:sp>
+      <p:sp>
+        <p:nvSpPr>
+          <p:cNvPr id="0" name="TB"/>
+          <p:cNvSpPr txBox="1"/>
+          <p:nvPr/>
+        </p:nvSpPr>
+        <p:spPr>
+          <a:xfrm>
+            <a:off x="2286000" y="5568696"/>
+            <a:ext cx="4572000" cy="384048"/>
+          </a:xfrm>
+          <a:prstGeom prst="rect">
+            <a:avLst/>
+          </a:prstGeom>
+          <a:noFill/>
+        </p:spPr>
+        <p:txBody>
+          <a:bodyPr wrap="square" rtlCol="0"/>
+          <a:lstStyle/>
+          <a:p>
+            <a:pPr algn="l"/>
+            <a:r>
+              <a:rPr lang="en-US" sz="1100" dirty="0">
+                <a:solidFill>
+                  <a:srgbClr val="FFFFFF"/>
+                </a:solidFill>
+                <a:latin typeface="Calibri"/>
+              </a:rPr>
+              <a:t>39th National Games</a:t>
+            </a:r>
+          </a:p>
+        </p:txBody>
+      </p:sp>
+      <p:sp>
+        <p:nvSpPr>
+          <p:cNvPr id="0" name="TB"/>
+          <p:cNvSpPr txBox="1"/>
+          <p:nvPr/>
+        </p:nvSpPr>
+        <p:spPr>
+          <a:xfrm>
+            <a:off x="7315200" y="5568696"/>
+            <a:ext cx="3840480" cy="384048"/>
+          </a:xfrm>
+          <a:prstGeom prst="rect">
+            <a:avLst/>
+          </a:prstGeom>
+          <a:noFill/>
+        </p:spPr>
+        <p:txBody>
+          <a:bodyPr wrap="square" rtlCol="0"/>
+          <a:lstStyle/>
+          <a:p>
+            <a:pPr algn="l"/>
+            <a:r>
+              <a:rPr lang="en-US" sz="1100" b="1" dirty="0">
+                <a:solidFill>
+                  <a:srgbClr val="E0A458"/>
+                </a:solidFill>
+                <a:latin typeface="Calibri"/>
+              </a:rPr>
+              <a:t>Uttarakhand</a:t>
+            </a:r>
+          </a:p>
+        </p:txBody>
+      </p:sp>
+      <p:sp>
+        <p:nvSpPr>
+          <p:cNvPr id="0" name="TB"/>
+          <p:cNvSpPr txBox="1"/>
+          <p:nvPr/>
+        </p:nvSpPr>
+        <p:spPr>
+          <a:xfrm>
+            <a:off x="640080" y="6126480"/>
+            <a:ext cx="10698480" cy="365760"/>
+          </a:xfrm>
+          <a:prstGeom prst="rect">
+            <a:avLst/>
+          </a:prstGeom>
+          <a:noFill/>
+        </p:spPr>
+        <p:txBody>
+          <a:bodyPr wrap="square" rtlCol="0"/>
+          <a:lstStyle/>
+          <a:p>
+            <a:pPr algn="ctr"/>
+            <a:r>
+              <a:rPr lang="en-US" sz="1200" dirty="0">
+                <a:solidFill>
+                  <a:srgbClr val="3F7D58"/>
+                </a:solidFill>
+                <a:latin typeface="Calibri"/>
+              </a:rPr>
+              <a:t>Ye sab recent 6 months ke facts hain — Lower PCS mein bhi expect karo!</a:t>
+            </a:r>
+          </a:p>
+        </p:txBody>
+      </p:sp>
     </p:spTree>
   </p:cSld>
-  <p:clrMapOvr><a:masterClrMapping/></p:clrMapOvr>
+  <p:clrMapOvr>
+    <a:masterClrMapping/>
+  </p:clrMapOvr>
 </p:sld>
 </file>
 
@@ -5040,314 +6466,1303 @@
 </p:sld>
 </file>
 
-<file path=ppt/slides/slide7.xml><?xml version="1.0" encoding="UTF-8" standalone="yes"?>
-<p:sld xmlns:a="http://schemas.openxmlformats.org/drawingml/2006/main"
-       xmlns:r="http://schemas.openxmlformats.org/officeDocument/2006/relationships"
-       xmlns:p="http://schemas.openxmlformats.org/presentationml/2006/main">
+<file path=ppt/slides/slide7.xml><?xml version="1.0" encoding="utf-8"?>
+<p:sld xmlns:a="http://schemas.openxmlformats.org/drawingml/2006/main" xmlns:r="http://schemas.openxmlformats.org/officeDocument/2006/relationships" xmlns:p="http://schemas.openxmlformats.org/presentationml/2006/main">
   <p:cSld>
-    <p:bg><p:bgPr><a:solidFill><a:srgbClr val="16233A"/></a:solidFill><a:effectLst/></p:bgPr></p:bg>
+    <p:bg>
+      <p:bgPr>
+        <a:solidFill>
+          <a:srgbClr val="16233A"/>
+        </a:solidFill>
+        <a:effectLst/>
+      </p:bgPr>
+    </p:bg>
     <p:spTree>
-      <p:nvGrpSpPr><p:cNvPr id="1" name=""/><p:cNvGrpSpPr/><p:nvPr/></p:nvGrpSpPr>
+      <p:nvGrpSpPr>
+        <p:cNvPr id="1" name=""/>
+        <p:cNvGrpSpPr/>
+        <p:nvPr/>
+      </p:nvGrpSpPr>
       <p:grpSpPr>
-        <a:xfrm><a:off x="0" y="0"/><a:ext cx="0" cy="0"/><a:chOff x="0" y="0"/><a:chExt cx="0" cy="0"/></a:xfrm>
+        <a:xfrm>
+          <a:off x="0" y="0"/>
+          <a:ext cx="0" cy="0"/>
+          <a:chOff x="0" y="0"/>
+          <a:chExt cx="0" cy="0"/>
+        </a:xfrm>
       </p:grpSpPr>
       <p:sp>
-  <p:nvSpPr><p:cNvPr id="0" name="TB"/><p:cNvSpPr txBox="1"/><p:nvPr/></p:nvSpPr>
-  <p:spPr>
-    <a:xfrm><a:off x="640080" y="274320"/><a:ext cx="10972800" cy="548640"/></a:xfrm>
-    <a:prstGeom prst="rect"><a:avLst/></a:prstGeom><a:noFill/>
-  </p:spPr>
-  <p:txBody><a:bodyPr wrap="square" rtlCol="0"/><a:lstStyle/><a:p><a:pPr algn="l"/><a:r><a:rPr lang="en-US" sz="2600" b="1" dirty="0"><a:solidFill><a:srgbClr val="FFFFFF"/></a:solidFill><a:latin typeface="Calibri"/></a:rPr><a:t>Section-wise Difficulty Analysis</a:t></a:r></a:p></p:txBody>
-</p:sp><p:sp>
-  <p:nvSpPr><p:cNvPr id="0" name="DH"/><p:cNvSpPr/><p:nvPr/></p:nvSpPr>
-  <p:spPr>
-    <a:xfrm><a:off x="640080" y="1005840"/><a:ext cx="10698480" cy="502920"/></a:xfrm>
-    <a:prstGeom prst="roundRect"><a:avLst><a:gd name="adj" fmla="val 5000"/></a:avLst></a:prstGeom>
-    <a:solidFill><a:srgbClr val="2E4057"/></a:solidFill>
-    <a:ln><a:noFill/></a:ln>
-  </p:spPr>
-  <p:txBody><a:bodyPr/><a:lstStyle/><a:p><a:endParaRPr lang="en-US"/></a:p></p:txBody>
-</p:sp><p:sp>
-  <p:nvSpPr><p:cNvPr id="0" name="TB"/><p:cNvSpPr txBox="1"/><p:nvPr/></p:nvSpPr>
-  <p:spPr>
-    <a:xfrm><a:off x="822960" y="1051560"/><a:ext cx="4572000" cy="411480"/></a:xfrm>
-    <a:prstGeom prst="rect"><a:avLst/></a:prstGeom><a:noFill/>
-  </p:spPr>
-  <p:txBody><a:bodyPr wrap="square" rtlCol="0"/><a:lstStyle/><a:p><a:pPr algn="l"/><a:r><a:rPr lang="en-US" sz="1200" b="1" dirty="0"><a:solidFill><a:srgbClr val="FFFFFF"/></a:solidFill><a:latin typeface="Calibri"/></a:rPr><a:t>Section</a:t></a:r></a:p></p:txBody>
-</p:sp><p:sp>
-  <p:nvSpPr><p:cNvPr id="0" name="TB"/><p:cNvSpPr txBox="1"/><p:nvPr/></p:nvSpPr>
-  <p:spPr>
-    <a:xfrm><a:off x="5943600" y="1051560"/><a:ext cx="2286000" cy="411480"/></a:xfrm>
-    <a:prstGeom prst="rect"><a:avLst/></a:prstGeom><a:noFill/>
-  </p:spPr>
-  <p:txBody><a:bodyPr wrap="square" rtlCol="0"/><a:lstStyle/><a:p><a:pPr algn="ctr"/><a:r><a:rPr lang="en-US" sz="1200" b="1" dirty="0"><a:solidFill><a:srgbClr val="FFFFFF"/></a:solidFill><a:latin typeface="Calibri"/></a:rPr><a:t>Difficulty</a:t></a:r></a:p></p:txBody>
-</p:sp><p:sp>
-  <p:nvSpPr><p:cNvPr id="0" name="TB"/><p:cNvSpPr txBox="1"/><p:nvPr/></p:nvSpPr>
-  <p:spPr>
-    <a:xfrm><a:off x="8686800" y="1051560"/><a:ext cx="2286000" cy="411480"/></a:xfrm>
-    <a:prstGeom prst="rect"><a:avLst/></a:prstGeom><a:noFill/>
-  </p:spPr>
-  <p:txBody><a:bodyPr wrap="square" rtlCol="0"/><a:lstStyle/><a:p><a:pPr algn="ctr"/><a:r><a:rPr lang="en-US" sz="1200" b="1" dirty="0"><a:solidFill><a:srgbClr val="FFFFFF"/></a:solidFill><a:latin typeface="Calibri"/></a:rPr><a:t>Approx Qs</a:t></a:r></a:p></p:txBody>
-</p:sp><p:sp>
-  <p:nvSpPr><p:cNvPr id="0" name="D0"/><p:cNvSpPr/><p:nvPr/></p:nvSpPr>
-  <p:spPr>
-    <a:xfrm><a:off x="640080" y="1600200"/><a:ext cx="10698480" cy="521207"/></a:xfrm>
-    <a:prstGeom prst="roundRect"><a:avLst><a:gd name="adj" fmla="val 5000"/></a:avLst></a:prstGeom>
-    <a:solidFill><a:srgbClr val="16233A"/></a:solidFill>
-    <a:ln><a:noFill/></a:ln>
-  </p:spPr>
-  <p:txBody><a:bodyPr/><a:lstStyle/><a:p><a:endParaRPr lang="en-US"/></a:p></p:txBody>
-</p:sp><p:sp>
-  <p:nvSpPr><p:cNvPr id="0" name="TB"/><p:cNvSpPr txBox="1"/><p:nvPr/></p:nvSpPr>
-  <p:spPr>
-    <a:xfrm><a:off x="822960" y="1645920"/><a:ext cx="4846320" cy="429768"/></a:xfrm>
-    <a:prstGeom prst="rect"><a:avLst/></a:prstGeom><a:noFill/>
-  </p:spPr>
-  <p:txBody><a:bodyPr wrap="square" rtlCol="0"/><a:lstStyle/><a:p><a:pPr algn="l"/><a:r><a:rPr lang="en-US" sz="1200" dirty="0"><a:solidFill><a:srgbClr val="FFFFFF"/></a:solidFill><a:latin typeface="Calibri"/></a:rPr><a:t>Legal Maxims (Q35-54)</a:t></a:r></a:p></p:txBody>
-</p:sp><p:sp>
-  <p:nvSpPr><p:cNvPr id="0" name="TB"/><p:cNvSpPr txBox="1"/><p:nvPr/></p:nvSpPr>
-  <p:spPr>
-    <a:xfrm><a:off x="5943600" y="1645920"/><a:ext cx="2286000" cy="429768"/></a:xfrm>
-    <a:prstGeom prst="rect"><a:avLst/></a:prstGeom><a:noFill/>
-  </p:spPr>
-  <p:txBody><a:bodyPr wrap="square" rtlCol="0"/><a:lstStyle/><a:p><a:pPr algn="ctr"/><a:r><a:rPr lang="en-US" sz="1200" b="1" dirty="0"><a:solidFill><a:srgbClr val="DC3545"/></a:solidFill><a:latin typeface="Calibri"/></a:rPr><a:t>Moderate-Tough</a:t></a:r></a:p></p:txBody>
-</p:sp><p:sp>
-  <p:nvSpPr><p:cNvPr id="0" name="TB"/><p:cNvSpPr txBox="1"/><p:nvPr/></p:nvSpPr>
-  <p:spPr>
-    <a:xfrm><a:off x="8686800" y="1645920"/><a:ext cx="2286000" cy="429768"/></a:xfrm>
-    <a:prstGeom prst="rect"><a:avLst/></a:prstGeom><a:noFill/>
-  </p:spPr>
-  <p:txBody><a:bodyPr wrap="square" rtlCol="0"/><a:lstStyle/><a:p><a:pPr algn="ctr"/><a:r><a:rPr lang="en-US" sz="1200" dirty="0"><a:solidFill><a:srgbClr val="C7CFDB"/></a:solidFill><a:latin typeface="Calibri"/></a:rPr><a:t>20+</a:t></a:r></a:p></p:txBody>
-</p:sp><p:sp>
-  <p:nvSpPr><p:cNvPr id="0" name="D1"/><p:cNvSpPr/><p:nvPr/></p:nvSpPr>
-  <p:spPr>
-    <a:xfrm><a:off x="640080" y="2167128"/><a:ext cx="10698480" cy="521207"/></a:xfrm>
-    <a:prstGeom prst="roundRect"><a:avLst><a:gd name="adj" fmla="val 5000"/></a:avLst></a:prstGeom>
-    <a:solidFill><a:srgbClr val="2E4057"/></a:solidFill>
-    <a:ln><a:noFill/></a:ln>
-  </p:spPr>
-  <p:txBody><a:bodyPr/><a:lstStyle/><a:p><a:endParaRPr lang="en-US"/></a:p></p:txBody>
-</p:sp><p:sp>
-  <p:nvSpPr><p:cNvPr id="0" name="TB"/><p:cNvSpPr txBox="1"/><p:nvPr/></p:nvSpPr>
-  <p:spPr>
-    <a:xfrm><a:off x="822960" y="2212848"/><a:ext cx="4846320" cy="429768"/></a:xfrm>
-    <a:prstGeom prst="rect"><a:avLst/></a:prstGeom><a:noFill/>
-  </p:spPr>
-  <p:txBody><a:bodyPr wrap="square" rtlCol="0"/><a:lstStyle/><a:p><a:pPr algn="l"/><a:r><a:rPr lang="en-US" sz="1200" dirty="0"><a:solidFill><a:srgbClr val="FFFFFF"/></a:solidFill><a:latin typeface="Calibri"/></a:rPr><a:t>Legal History (Q59-68)</a:t></a:r></a:p></p:txBody>
-</p:sp><p:sp>
-  <p:nvSpPr><p:cNvPr id="0" name="TB"/><p:cNvSpPr txBox="1"/><p:nvPr/></p:nvSpPr>
-  <p:spPr>
-    <a:xfrm><a:off x="5943600" y="2212848"/><a:ext cx="2286000" cy="429768"/></a:xfrm>
-    <a:prstGeom prst="rect"><a:avLst/></a:prstGeom><a:noFill/>
-  </p:spPr>
-  <p:txBody><a:bodyPr wrap="square" rtlCol="0"/><a:lstStyle/><a:p><a:pPr algn="ctr"/><a:r><a:rPr lang="en-US" sz="1200" b="1" dirty="0"><a:solidFill><a:srgbClr val="F59E0B"/></a:solidFill><a:latin typeface="Calibri"/></a:rPr><a:t>Moderate</a:t></a:r></a:p></p:txBody>
-</p:sp><p:sp>
-  <p:nvSpPr><p:cNvPr id="0" name="TB"/><p:cNvSpPr txBox="1"/><p:nvPr/></p:nvSpPr>
-  <p:spPr>
-    <a:xfrm><a:off x="8686800" y="2212848"/><a:ext cx="2286000" cy="429768"/></a:xfrm>
-    <a:prstGeom prst="rect"><a:avLst/></a:prstGeom><a:noFill/>
-  </p:spPr>
-  <p:txBody><a:bodyPr wrap="square" rtlCol="0"/><a:lstStyle/><a:p><a:pPr algn="ctr"/><a:r><a:rPr lang="en-US" sz="1200" dirty="0"><a:solidFill><a:srgbClr val="C7CFDB"/></a:solidFill><a:latin typeface="Calibri"/></a:rPr><a:t>~15</a:t></a:r></a:p></p:txBody>
-</p:sp><p:sp>
-  <p:nvSpPr><p:cNvPr id="0" name="D2"/><p:cNvSpPr/><p:nvPr/></p:nvSpPr>
-  <p:spPr>
-    <a:xfrm><a:off x="640080" y="2734056"/><a:ext cx="10698480" cy="521207"/></a:xfrm>
-    <a:prstGeom prst="roundRect"><a:avLst><a:gd name="adj" fmla="val 5000"/></a:avLst></a:prstGeom>
-    <a:solidFill><a:srgbClr val="16233A"/></a:solidFill>
-    <a:ln><a:noFill/></a:ln>
-  </p:spPr>
-  <p:txBody><a:bodyPr/><a:lstStyle/><a:p><a:endParaRPr lang="en-US"/></a:p></p:txBody>
-</p:sp><p:sp>
-  <p:nvSpPr><p:cNvPr id="0" name="TB"/><p:cNvSpPr txBox="1"/><p:nvPr/></p:nvSpPr>
-  <p:spPr>
-    <a:xfrm><a:off x="822960" y="2779776"/><a:ext cx="4846320" cy="429768"/></a:xfrm>
-    <a:prstGeom prst="rect"><a:avLst/></a:prstGeom><a:noFill/>
-  </p:spPr>
-  <p:txBody><a:bodyPr wrap="square" rtlCol="0"/><a:lstStyle/><a:p><a:pPr algn="l"/><a:r><a:rPr lang="en-US" sz="1200" dirty="0"><a:solidFill><a:srgbClr val="FFFFFF"/></a:solidFill><a:latin typeface="Calibri"/></a:rPr><a:t>Indian Polity (Q110-117)</a:t></a:r></a:p></p:txBody>
-</p:sp><p:sp>
-  <p:nvSpPr><p:cNvPr id="0" name="TB"/><p:cNvSpPr txBox="1"/><p:nvPr/></p:nvSpPr>
-  <p:spPr>
-    <a:xfrm><a:off x="5943600" y="2779776"/><a:ext cx="2286000" cy="429768"/></a:xfrm>
-    <a:prstGeom prst="rect"><a:avLst/></a:prstGeom><a:noFill/>
-  </p:spPr>
-  <p:txBody><a:bodyPr wrap="square" rtlCol="0"/><a:lstStyle/><a:p><a:pPr algn="ctr"/><a:r><a:rPr lang="en-US" sz="1200" b="1" dirty="0"><a:solidFill><a:srgbClr val="3F7D58"/></a:solidFill><a:latin typeface="Calibri"/></a:rPr><a:t>Easy-Moderate</a:t></a:r></a:p></p:txBody>
-</p:sp><p:sp>
-  <p:nvSpPr><p:cNvPr id="0" name="TB"/><p:cNvSpPr txBox="1"/><p:nvPr/></p:nvSpPr>
-  <p:spPr>
-    <a:xfrm><a:off x="8686800" y="2779776"/><a:ext cx="2286000" cy="429768"/></a:xfrm>
-    <a:prstGeom prst="rect"><a:avLst/></a:prstGeom><a:noFill/>
-  </p:spPr>
-  <p:txBody><a:bodyPr wrap="square" rtlCol="0"/><a:lstStyle/><a:p><a:pPr algn="ctr"/><a:r><a:rPr lang="en-US" sz="1200" dirty="0"><a:solidFill><a:srgbClr val="C7CFDB"/></a:solidFill><a:latin typeface="Calibri"/></a:rPr><a:t>~15</a:t></a:r></a:p></p:txBody>
-</p:sp><p:sp>
-  <p:nvSpPr><p:cNvPr id="0" name="D3"/><p:cNvSpPr/><p:nvPr/></p:nvSpPr>
-  <p:spPr>
-    <a:xfrm><a:off x="640080" y="3300984"/><a:ext cx="10698480" cy="521207"/></a:xfrm>
-    <a:prstGeom prst="roundRect"><a:avLst><a:gd name="adj" fmla="val 5000"/></a:avLst></a:prstGeom>
-    <a:solidFill><a:srgbClr val="2E4057"/></a:solidFill>
-    <a:ln><a:noFill/></a:ln>
-  </p:spPr>
-  <p:txBody><a:bodyPr/><a:lstStyle/><a:p><a:endParaRPr lang="en-US"/></a:p></p:txBody>
-</p:sp><p:sp>
-  <p:nvSpPr><p:cNvPr id="0" name="TB"/><p:cNvSpPr txBox="1"/><p:nvPr/></p:nvSpPr>
-  <p:spPr>
-    <a:xfrm><a:off x="822960" y="3346704"/><a:ext cx="4846320" cy="429768"/></a:xfrm>
-    <a:prstGeom prst="rect"><a:avLst/></a:prstGeom><a:noFill/>
-  </p:spPr>
-  <p:txBody><a:bodyPr wrap="square" rtlCol="0"/><a:lstStyle/><a:p><a:pPr algn="l"/><a:r><a:rPr lang="en-US" sz="1200" dirty="0"><a:solidFill><a:srgbClr val="FFFFFF"/></a:solidFill><a:latin typeface="Calibri"/></a:rPr><a:t>UK History & Culture (Q72-96)</a:t></a:r></a:p></p:txBody>
-</p:sp><p:sp>
-  <p:nvSpPr><p:cNvPr id="0" name="TB"/><p:cNvSpPr txBox="1"/><p:nvPr/></p:nvSpPr>
-  <p:spPr>
-    <a:xfrm><a:off x="5943600" y="3346704"/><a:ext cx="2286000" cy="429768"/></a:xfrm>
-    <a:prstGeom prst="rect"><a:avLst/></a:prstGeom><a:noFill/>
-  </p:spPr>
-  <p:txBody><a:bodyPr wrap="square" rtlCol="0"/><a:lstStyle/><a:p><a:pPr algn="ctr"/><a:r><a:rPr lang="en-US" sz="1200" b="1" dirty="0"><a:solidFill><a:srgbClr val="DC3545"/></a:solidFill><a:latin typeface="Calibri"/></a:rPr><a:t>Tough</a:t></a:r></a:p></p:txBody>
-</p:sp><p:sp>
-  <p:nvSpPr><p:cNvPr id="0" name="TB"/><p:cNvSpPr txBox="1"/><p:nvPr/></p:nvSpPr>
-  <p:spPr>
-    <a:xfrm><a:off x="8686800" y="3346704"/><a:ext cx="2286000" cy="429768"/></a:xfrm>
-    <a:prstGeom prst="rect"><a:avLst/></a:prstGeom><a:noFill/>
-  </p:spPr>
-  <p:txBody><a:bodyPr wrap="square" rtlCol="0"/><a:lstStyle/><a:p><a:pPr algn="ctr"/><a:r><a:rPr lang="en-US" sz="1200" dirty="0"><a:solidFill><a:srgbClr val="C7CFDB"/></a:solidFill><a:latin typeface="Calibri"/></a:rPr><a:t>~40</a:t></a:r></a:p></p:txBody>
-</p:sp><p:sp>
-  <p:nvSpPr><p:cNvPr id="0" name="D4"/><p:cNvSpPr/><p:nvPr/></p:nvSpPr>
-  <p:spPr>
-    <a:xfrm><a:off x="640080" y="3867912"/><a:ext cx="10698480" cy="521207"/></a:xfrm>
-    <a:prstGeom prst="roundRect"><a:avLst><a:gd name="adj" fmla="val 5000"/></a:avLst></a:prstGeom>
-    <a:solidFill><a:srgbClr val="16233A"/></a:solidFill>
-    <a:ln><a:noFill/></a:ln>
-  </p:spPr>
-  <p:txBody><a:bodyPr/><a:lstStyle/><a:p><a:endParaRPr lang="en-US"/></a:p></p:txBody>
-</p:sp><p:sp>
-  <p:nvSpPr><p:cNvPr id="0" name="TB"/><p:cNvSpPr txBox="1"/><p:nvPr/></p:nvSpPr>
-  <p:spPr>
-    <a:xfrm><a:off x="822960" y="3913632"/><a:ext cx="4846320" cy="429768"/></a:xfrm>
-    <a:prstGeom prst="rect"><a:avLst/></a:prstGeom><a:noFill/>
-  </p:spPr>
-  <p:txBody><a:bodyPr wrap="square" rtlCol="0"/><a:lstStyle/><a:p><a:pPr algn="l"/><a:r><a:rPr lang="en-US" sz="1200" dirty="0"><a:solidFill><a:srgbClr val="FFFFFF"/></a:solidFill><a:latin typeface="Calibri"/></a:rPr><a:t>UK Current & Schemes (Q97-109)</a:t></a:r></a:p></p:txBody>
-</p:sp><p:sp>
-  <p:nvSpPr><p:cNvPr id="0" name="TB"/><p:cNvSpPr txBox="1"/><p:nvPr/></p:nvSpPr>
-  <p:spPr>
-    <a:xfrm><a:off x="5943600" y="3913632"/><a:ext cx="2286000" cy="429768"/></a:xfrm>
-    <a:prstGeom prst="rect"><a:avLst/></a:prstGeom><a:noFill/>
-  </p:spPr>
-  <p:txBody><a:bodyPr wrap="square" rtlCol="0"/><a:lstStyle/><a:p><a:pPr algn="ctr"/><a:r><a:rPr lang="en-US" sz="1200" b="1" dirty="0"><a:solidFill><a:srgbClr val="F59E0B"/></a:solidFill><a:latin typeface="Calibri"/></a:rPr><a:t>Moderate</a:t></a:r></a:p></p:txBody>
-</p:sp><p:sp>
-  <p:nvSpPr><p:cNvPr id="0" name="TB"/><p:cNvSpPr txBox="1"/><p:nvPr/></p:nvSpPr>
-  <p:spPr>
-    <a:xfrm><a:off x="8686800" y="3913632"/><a:ext cx="2286000" cy="429768"/></a:xfrm>
-    <a:prstGeom prst="rect"><a:avLst/></a:prstGeom><a:noFill/>
-  </p:spPr>
-  <p:txBody><a:bodyPr wrap="square" rtlCol="0"/><a:lstStyle/><a:p><a:pPr algn="ctr"/><a:r><a:rPr lang="en-US" sz="1200" dirty="0"><a:solidFill><a:srgbClr val="C7CFDB"/></a:solidFill><a:latin typeface="Calibri"/></a:rPr><a:t>~15</a:t></a:r></a:p></p:txBody>
-</p:sp><p:sp>
-  <p:nvSpPr><p:cNvPr id="0" name="D5"/><p:cNvSpPr/><p:nvPr/></p:nvSpPr>
-  <p:spPr>
-    <a:xfrm><a:off x="640080" y="4434840"/><a:ext cx="10698480" cy="521207"/></a:xfrm>
-    <a:prstGeom prst="roundRect"><a:avLst><a:gd name="adj" fmla="val 5000"/></a:avLst></a:prstGeom>
-    <a:solidFill><a:srgbClr val="2E4057"/></a:solidFill>
-    <a:ln><a:noFill/></a:ln>
-  </p:spPr>
-  <p:txBody><a:bodyPr/><a:lstStyle/><a:p><a:endParaRPr lang="en-US"/></a:p></p:txBody>
-</p:sp><p:sp>
-  <p:nvSpPr><p:cNvPr id="0" name="TB"/><p:cNvSpPr txBox="1"/><p:nvPr/></p:nvSpPr>
-  <p:spPr>
-    <a:xfrm><a:off x="822960" y="4480560"/><a:ext cx="4846320" cy="429768"/></a:xfrm>
-    <a:prstGeom prst="rect"><a:avLst/></a:prstGeom><a:noFill/>
-  </p:spPr>
-  <p:txBody><a:bodyPr wrap="square" rtlCol="0"/><a:lstStyle/><a:p><a:pPr algn="l"/><a:r><a:rPr lang="en-US" sz="1200" dirty="0"><a:solidFill><a:srgbClr val="FFFFFF"/></a:solidFill><a:latin typeface="Calibri"/></a:rPr><a:t>National Current Affairs (Q177-195)</a:t></a:r></a:p></p:txBody>
-</p:sp><p:sp>
-  <p:nvSpPr><p:cNvPr id="0" name="TB"/><p:cNvSpPr txBox="1"/><p:nvPr/></p:nvSpPr>
-  <p:spPr>
-    <a:xfrm><a:off x="5943600" y="4480560"/><a:ext cx="2286000" cy="429768"/></a:xfrm>
-    <a:prstGeom prst="rect"><a:avLst/></a:prstGeom><a:noFill/>
-  </p:spPr>
-  <p:txBody><a:bodyPr wrap="square" rtlCol="0"/><a:lstStyle/><a:p><a:pPr algn="ctr"/><a:r><a:rPr lang="en-US" sz="1200" b="1" dirty="0"><a:solidFill><a:srgbClr val="3F7D58"/></a:solidFill><a:latin typeface="Calibri"/></a:rPr><a:t>Easy-Moderate</a:t></a:r></a:p></p:txBody>
-</p:sp><p:sp>
-  <p:nvSpPr><p:cNvPr id="0" name="TB"/><p:cNvSpPr txBox="1"/><p:nvPr/></p:nvSpPr>
-  <p:spPr>
-    <a:xfrm><a:off x="8686800" y="4480560"/><a:ext cx="2286000" cy="429768"/></a:xfrm>
-    <a:prstGeom prst="rect"><a:avLst/></a:prstGeom><a:noFill/>
-  </p:spPr>
-  <p:txBody><a:bodyPr wrap="square" rtlCol="0"/><a:lstStyle/><a:p><a:pPr algn="ctr"/><a:r><a:rPr lang="en-US" sz="1200" dirty="0"><a:solidFill><a:srgbClr val="C7CFDB"/></a:solidFill><a:latin typeface="Calibri"/></a:rPr><a:t>~20</a:t></a:r></a:p></p:txBody>
-</p:sp><p:sp>
-  <p:nvSpPr><p:cNvPr id="0" name="D6"/><p:cNvSpPr/><p:nvPr/></p:nvSpPr>
-  <p:spPr>
-    <a:xfrm><a:off x="640080" y="5001768"/><a:ext cx="10698480" cy="521207"/></a:xfrm>
-    <a:prstGeom prst="roundRect"><a:avLst><a:gd name="adj" fmla="val 5000"/></a:avLst></a:prstGeom>
-    <a:solidFill><a:srgbClr val="16233A"/></a:solidFill>
-    <a:ln><a:noFill/></a:ln>
-  </p:spPr>
-  <p:txBody><a:bodyPr/><a:lstStyle/><a:p><a:endParaRPr lang="en-US"/></a:p></p:txBody>
-</p:sp><p:sp>
-  <p:nvSpPr><p:cNvPr id="0" name="TB"/><p:cNvSpPr txBox="1"/><p:nvPr/></p:nvSpPr>
-  <p:spPr>
-    <a:xfrm><a:off x="822960" y="5047488"/><a:ext cx="4846320" cy="429768"/></a:xfrm>
-    <a:prstGeom prst="rect"><a:avLst/></a:prstGeom><a:noFill/>
-  </p:spPr>
-  <p:txBody><a:bodyPr wrap="square" rtlCol="0"/><a:lstStyle/><a:p><a:pPr algn="l"/><a:r><a:rPr lang="en-US" sz="1200" dirty="0"><a:solidFill><a:srgbClr val="FFFFFF"/></a:solidFill><a:latin typeface="Calibri"/></a:rPr><a:t>Science & Computer</a:t></a:r></a:p></p:txBody>
-</p:sp><p:sp>
-  <p:nvSpPr><p:cNvPr id="0" name="TB"/><p:cNvSpPr txBox="1"/><p:nvPr/></p:nvSpPr>
-  <p:spPr>
-    <a:xfrm><a:off x="5943600" y="5047488"/><a:ext cx="2286000" cy="429768"/></a:xfrm>
-    <a:prstGeom prst="rect"><a:avLst/></a:prstGeom><a:noFill/>
-  </p:spPr>
-  <p:txBody><a:bodyPr wrap="square" rtlCol="0"/><a:lstStyle/><a:p><a:pPr algn="ctr"/><a:r><a:rPr lang="en-US" sz="1200" b="1" dirty="0"><a:solidFill><a:srgbClr val="F59E0B"/></a:solidFill><a:latin typeface="Calibri"/></a:rPr><a:t>Moderate</a:t></a:r></a:p></p:txBody>
-</p:sp><p:sp>
-  <p:nvSpPr><p:cNvPr id="0" name="TB"/><p:cNvSpPr txBox="1"/><p:nvPr/></p:nvSpPr>
-  <p:spPr>
-    <a:xfrm><a:off x="8686800" y="5047488"/><a:ext cx="2286000" cy="429768"/></a:xfrm>
-    <a:prstGeom prst="rect"><a:avLst/></a:prstGeom><a:noFill/>
-  </p:spPr>
-  <p:txBody><a:bodyPr wrap="square" rtlCol="0"/><a:lstStyle/><a:p><a:pPr algn="ctr"/><a:r><a:rPr lang="en-US" sz="1200" dirty="0"><a:solidFill><a:srgbClr val="C7CFDB"/></a:solidFill><a:latin typeface="Calibri"/></a:rPr><a:t>~15</a:t></a:r></a:p></p:txBody>
-</p:sp><p:sp>
-  <p:nvSpPr><p:cNvPr id="0" name="D7"/><p:cNvSpPr/><p:nvPr/></p:nvSpPr>
-  <p:spPr>
-    <a:xfrm><a:off x="640080" y="5568696"/><a:ext cx="10698480" cy="521207"/></a:xfrm>
-    <a:prstGeom prst="roundRect"><a:avLst><a:gd name="adj" fmla="val 5000"/></a:avLst></a:prstGeom>
-    <a:solidFill><a:srgbClr val="2E4057"/></a:solidFill>
-    <a:ln><a:noFill/></a:ln>
-  </p:spPr>
-  <p:txBody><a:bodyPr/><a:lstStyle/><a:p><a:endParaRPr lang="en-US"/></a:p></p:txBody>
-</p:sp><p:sp>
-  <p:nvSpPr><p:cNvPr id="0" name="TB"/><p:cNvSpPr txBox="1"/><p:nvPr/></p:nvSpPr>
-  <p:spPr>
-    <a:xfrm><a:off x="822960" y="5614416"/><a:ext cx="4846320" cy="429768"/></a:xfrm>
-    <a:prstGeom prst="rect"><a:avLst/></a:prstGeom><a:noFill/>
-  </p:spPr>
-  <p:txBody><a:bodyPr wrap="square" rtlCol="0"/><a:lstStyle/><a:p><a:pPr algn="l"/><a:r><a:rPr lang="en-US" sz="1200" dirty="0"><a:solidFill><a:srgbClr val="FFFFFF"/></a:solidFill><a:latin typeface="Calibri"/></a:rPr><a:t>Maths & Reasoning</a:t></a:r></a:p></p:txBody>
-</p:sp><p:sp>
-  <p:nvSpPr><p:cNvPr id="0" name="TB"/><p:cNvSpPr txBox="1"/><p:nvPr/></p:nvSpPr>
-  <p:spPr>
-    <a:xfrm><a:off x="5943600" y="5614416"/><a:ext cx="2286000" cy="429768"/></a:xfrm>
-    <a:prstGeom prst="rect"><a:avLst/></a:prstGeom><a:noFill/>
-  </p:spPr>
-  <p:txBody><a:bodyPr wrap="square" rtlCol="0"/><a:lstStyle/><a:p><a:pPr algn="ctr"/><a:r><a:rPr lang="en-US" sz="1200" b="1" dirty="0"><a:solidFill><a:srgbClr val="F59E0B"/></a:solidFill><a:latin typeface="Calibri"/></a:rPr><a:t>Moderate</a:t></a:r></a:p></p:txBody>
-</p:sp><p:sp>
-  <p:nvSpPr><p:cNvPr id="0" name="TB"/><p:cNvSpPr txBox="1"/><p:nvPr/></p:nvSpPr>
-  <p:spPr>
-    <a:xfrm><a:off x="8686800" y="5614416"/><a:ext cx="2286000" cy="429768"/></a:xfrm>
-    <a:prstGeom prst="rect"><a:avLst/></a:prstGeom><a:noFill/>
-  </p:spPr>
-  <p:txBody><a:bodyPr wrap="square" rtlCol="0"/><a:lstStyle/><a:p><a:pPr algn="ctr"/><a:r><a:rPr lang="en-US" sz="1200" dirty="0"><a:solidFill><a:srgbClr val="C7CFDB"/></a:solidFill><a:latin typeface="Calibri"/></a:rPr><a:t>~20</a:t></a:r></a:p></p:txBody>
-</p:sp><p:sp>
-  <p:nvSpPr><p:cNvPr id="0" name="OV"/><p:cNvSpPr/><p:nvPr/></p:nvSpPr>
-  <p:spPr>
-    <a:xfrm><a:off x="640080" y="6035040"/><a:ext cx="10698480" cy="548640"/></a:xfrm>
-    <a:prstGeom prst="roundRect"><a:avLst><a:gd name="adj" fmla="val 5000"/></a:avLst></a:prstGeom>
-    <a:solidFill><a:srgbClr val="E0A458"/></a:solidFill>
-    <a:ln><a:noFill/></a:ln>
-  </p:spPr>
-  <p:txBody><a:bodyPr/><a:lstStyle/><a:p><a:endParaRPr lang="en-US"/></a:p></p:txBody>
-</p:sp><p:sp>
-  <p:nvSpPr><p:cNvPr id="0" name="TB"/><p:cNvSpPr txBox="1"/><p:nvPr/></p:nvSpPr>
-  <p:spPr>
-    <a:xfrm><a:off x="914400" y="6080760"/><a:ext cx="10241280" cy="457200"/></a:xfrm>
-    <a:prstGeom prst="rect"><a:avLst/></a:prstGeom><a:noFill/>
-  </p:spPr>
-  <p:txBody><a:bodyPr wrap="square" rtlCol="0"/><a:lstStyle/><a:p><a:pPr algn="ctr"/><a:r><a:rPr lang="en-US" sz="1400" b="1" dirty="0"><a:solidFill><a:srgbClr val="16233A"/></a:solidFill><a:latin typeface="Calibri"/></a:rPr><a:t>Overall Paper Level: MODERATE (with TOUGH Legal + UK History sections)</a:t></a:r></a:p></p:txBody>
-</p:sp>
+        <p:nvSpPr>
+          <p:cNvPr id="0" name="TB"/>
+          <p:cNvSpPr txBox="1"/>
+          <p:nvPr/>
+        </p:nvSpPr>
+        <p:spPr>
+          <a:xfrm>
+            <a:off x="640080" y="274320"/>
+            <a:ext cx="10972800" cy="548640"/>
+          </a:xfrm>
+          <a:prstGeom prst="rect">
+            <a:avLst/>
+          </a:prstGeom>
+          <a:noFill/>
+        </p:spPr>
+        <p:txBody>
+          <a:bodyPr wrap="square" rtlCol="0"/>
+          <a:lstStyle/>
+          <a:p>
+            <a:pPr algn="l"/>
+            <a:r>
+              <a:rPr lang="en-US" sz="2600" b="1" dirty="0">
+                <a:solidFill>
+                  <a:srgbClr val="FFFFFF"/>
+                </a:solidFill>
+                <a:latin typeface="Calibri"/>
+              </a:rPr>
+              <a:t>Section-wise Difficulty Analysis</a:t>
+            </a:r>
+          </a:p>
+        </p:txBody>
+      </p:sp>
+      <p:sp>
+        <p:nvSpPr>
+          <p:cNvPr id="0" name="DH"/>
+          <p:cNvSpPr/>
+          <p:nvPr/>
+        </p:nvSpPr>
+        <p:spPr>
+          <a:xfrm>
+            <a:off x="640080" y="1005840"/>
+            <a:ext cx="10698480" cy="502920"/>
+          </a:xfrm>
+          <a:prstGeom prst="roundRect">
+            <a:avLst>
+              <a:gd name="adj" fmla="val 5000"/>
+            </a:avLst>
+          </a:prstGeom>
+          <a:solidFill>
+            <a:srgbClr val="2E4057"/>
+          </a:solidFill>
+          <a:ln>
+            <a:noFill/>
+          </a:ln>
+        </p:spPr>
+        <p:txBody>
+          <a:bodyPr/>
+          <a:lstStyle/>
+          <a:p>
+            <a:endParaRPr lang="en-US"/>
+          </a:p>
+        </p:txBody>
+      </p:sp>
+      <p:sp>
+        <p:nvSpPr>
+          <p:cNvPr id="0" name="TB"/>
+          <p:cNvSpPr txBox="1"/>
+          <p:nvPr/>
+        </p:nvSpPr>
+        <p:spPr>
+          <a:xfrm>
+            <a:off x="822960" y="1051560"/>
+            <a:ext cx="4572000" cy="411480"/>
+          </a:xfrm>
+          <a:prstGeom prst="rect">
+            <a:avLst/>
+          </a:prstGeom>
+          <a:noFill/>
+        </p:spPr>
+        <p:txBody>
+          <a:bodyPr wrap="square" rtlCol="0"/>
+          <a:lstStyle/>
+          <a:p>
+            <a:pPr algn="l"/>
+            <a:r>
+              <a:rPr lang="en-US" sz="1200" b="1" dirty="0">
+                <a:solidFill>
+                  <a:srgbClr val="FFFFFF"/>
+                </a:solidFill>
+                <a:latin typeface="Calibri"/>
+              </a:rPr>
+              <a:t>Section</a:t>
+            </a:r>
+          </a:p>
+        </p:txBody>
+      </p:sp>
+      <p:sp>
+        <p:nvSpPr>
+          <p:cNvPr id="0" name="TB"/>
+          <p:cNvSpPr txBox="1"/>
+          <p:nvPr/>
+        </p:nvSpPr>
+        <p:spPr>
+          <a:xfrm>
+            <a:off x="5943600" y="1051560"/>
+            <a:ext cx="2286000" cy="411480"/>
+          </a:xfrm>
+          <a:prstGeom prst="rect">
+            <a:avLst/>
+          </a:prstGeom>
+          <a:noFill/>
+        </p:spPr>
+        <p:txBody>
+          <a:bodyPr wrap="square" rtlCol="0"/>
+          <a:lstStyle/>
+          <a:p>
+            <a:pPr algn="ctr"/>
+            <a:r>
+              <a:rPr lang="en-US" sz="1200" b="1" dirty="0">
+                <a:solidFill>
+                  <a:srgbClr val="FFFFFF"/>
+                </a:solidFill>
+                <a:latin typeface="Calibri"/>
+              </a:rPr>
+              <a:t>Difficulty</a:t>
+            </a:r>
+          </a:p>
+        </p:txBody>
+      </p:sp>
+      <p:sp>
+        <p:nvSpPr>
+          <p:cNvPr id="0" name="TB"/>
+          <p:cNvSpPr txBox="1"/>
+          <p:nvPr/>
+        </p:nvSpPr>
+        <p:spPr>
+          <a:xfrm>
+            <a:off x="8686800" y="1051560"/>
+            <a:ext cx="2286000" cy="411480"/>
+          </a:xfrm>
+          <a:prstGeom prst="rect">
+            <a:avLst/>
+          </a:prstGeom>
+          <a:noFill/>
+        </p:spPr>
+        <p:txBody>
+          <a:bodyPr wrap="square" rtlCol="0"/>
+          <a:lstStyle/>
+          <a:p>
+            <a:pPr algn="ctr"/>
+            <a:r>
+              <a:rPr lang="en-US" sz="1200" b="1" dirty="0">
+                <a:solidFill>
+                  <a:srgbClr val="FFFFFF"/>
+                </a:solidFill>
+                <a:latin typeface="Calibri"/>
+              </a:rPr>
+              <a:t>Approx Qs</a:t>
+            </a:r>
+          </a:p>
+        </p:txBody>
+      </p:sp>
+      <p:sp>
+        <p:nvSpPr>
+          <p:cNvPr id="0" name="D0"/>
+          <p:cNvSpPr/>
+          <p:nvPr/>
+        </p:nvSpPr>
+        <p:spPr>
+          <a:xfrm>
+            <a:off x="640080" y="1600200"/>
+            <a:ext cx="10698480" cy="521207"/>
+          </a:xfrm>
+          <a:prstGeom prst="roundRect">
+            <a:avLst>
+              <a:gd name="adj" fmla="val 5000"/>
+            </a:avLst>
+          </a:prstGeom>
+          <a:solidFill>
+            <a:srgbClr val="16233A"/>
+          </a:solidFill>
+          <a:ln>
+            <a:noFill/>
+          </a:ln>
+        </p:spPr>
+        <p:txBody>
+          <a:bodyPr/>
+          <a:lstStyle/>
+          <a:p>
+            <a:endParaRPr lang="en-US"/>
+          </a:p>
+        </p:txBody>
+      </p:sp>
+      <p:sp>
+        <p:nvSpPr>
+          <p:cNvPr id="0" name="TB"/>
+          <p:cNvSpPr txBox="1"/>
+          <p:nvPr/>
+        </p:nvSpPr>
+        <p:spPr>
+          <a:xfrm>
+            <a:off x="822960" y="1645920"/>
+            <a:ext cx="4846320" cy="429768"/>
+          </a:xfrm>
+          <a:prstGeom prst="rect">
+            <a:avLst/>
+          </a:prstGeom>
+          <a:noFill/>
+        </p:spPr>
+        <p:txBody>
+          <a:bodyPr wrap="square" rtlCol="0"/>
+          <a:lstStyle/>
+          <a:p>
+            <a:pPr algn="l"/>
+            <a:r>
+              <a:rPr lang="en-US" sz="1200" dirty="0">
+                <a:solidFill>
+                  <a:srgbClr val="FFFFFF"/>
+                </a:solidFill>
+                <a:latin typeface="Calibri"/>
+              </a:rPr>
+              <a:t>Legal Maxims (Q35-54)</a:t>
+            </a:r>
+          </a:p>
+        </p:txBody>
+      </p:sp>
+      <p:sp>
+        <p:nvSpPr>
+          <p:cNvPr id="0" name="TB"/>
+          <p:cNvSpPr txBox="1"/>
+          <p:nvPr/>
+        </p:nvSpPr>
+        <p:spPr>
+          <a:xfrm>
+            <a:off x="5943600" y="1645920"/>
+            <a:ext cx="2286000" cy="429768"/>
+          </a:xfrm>
+          <a:prstGeom prst="rect">
+            <a:avLst/>
+          </a:prstGeom>
+          <a:noFill/>
+        </p:spPr>
+        <p:txBody>
+          <a:bodyPr wrap="square" rtlCol="0"/>
+          <a:lstStyle/>
+          <a:p>
+            <a:pPr algn="ctr"/>
+            <a:r>
+              <a:rPr lang="en-US" sz="1200" b="1" dirty="0">
+                <a:solidFill>
+                  <a:srgbClr val="DC3545"/>
+                </a:solidFill>
+                <a:latin typeface="Calibri"/>
+              </a:rPr>
+              <a:t>Moderate-Tough</a:t>
+            </a:r>
+          </a:p>
+        </p:txBody>
+      </p:sp>
+      <p:sp>
+        <p:nvSpPr>
+          <p:cNvPr id="0" name="TB"/>
+          <p:cNvSpPr txBox="1"/>
+          <p:nvPr/>
+        </p:nvSpPr>
+        <p:spPr>
+          <a:xfrm>
+            <a:off x="8686800" y="1645920"/>
+            <a:ext cx="2286000" cy="429768"/>
+          </a:xfrm>
+          <a:prstGeom prst="rect">
+            <a:avLst/>
+          </a:prstGeom>
+          <a:noFill/>
+        </p:spPr>
+        <p:txBody>
+          <a:bodyPr wrap="square" rtlCol="0"/>
+          <a:lstStyle/>
+          <a:p>
+            <a:pPr algn="ctr"/>
+            <a:r>
+              <a:rPr lang="en-US" sz="1200" dirty="0">
+                <a:solidFill>
+                  <a:srgbClr val="C7CFDB"/>
+                </a:solidFill>
+                <a:latin typeface="Calibri"/>
+              </a:rPr>
+              <a:t>20+</a:t>
+            </a:r>
+          </a:p>
+        </p:txBody>
+      </p:sp>
+      <p:sp>
+        <p:nvSpPr>
+          <p:cNvPr id="0" name="D1"/>
+          <p:cNvSpPr/>
+          <p:nvPr/>
+        </p:nvSpPr>
+        <p:spPr>
+          <a:xfrm>
+            <a:off x="640080" y="2167128"/>
+            <a:ext cx="10698480" cy="521207"/>
+          </a:xfrm>
+          <a:prstGeom prst="roundRect">
+            <a:avLst>
+              <a:gd name="adj" fmla="val 5000"/>
+            </a:avLst>
+          </a:prstGeom>
+          <a:solidFill>
+            <a:srgbClr val="2E4057"/>
+          </a:solidFill>
+          <a:ln>
+            <a:noFill/>
+          </a:ln>
+        </p:spPr>
+        <p:txBody>
+          <a:bodyPr/>
+          <a:lstStyle/>
+          <a:p>
+            <a:endParaRPr lang="en-US"/>
+          </a:p>
+        </p:txBody>
+      </p:sp>
+      <p:sp>
+        <p:nvSpPr>
+          <p:cNvPr id="0" name="TB"/>
+          <p:cNvSpPr txBox="1"/>
+          <p:nvPr/>
+        </p:nvSpPr>
+        <p:spPr>
+          <a:xfrm>
+            <a:off x="822960" y="2212848"/>
+            <a:ext cx="4846320" cy="429768"/>
+          </a:xfrm>
+          <a:prstGeom prst="rect">
+            <a:avLst/>
+          </a:prstGeom>
+          <a:noFill/>
+        </p:spPr>
+        <p:txBody>
+          <a:bodyPr wrap="square" rtlCol="0"/>
+          <a:lstStyle/>
+          <a:p>
+            <a:pPr algn="l"/>
+            <a:r>
+              <a:rPr lang="en-US" sz="1200" dirty="0">
+                <a:solidFill>
+                  <a:srgbClr val="FFFFFF"/>
+                </a:solidFill>
+                <a:latin typeface="Calibri"/>
+              </a:rPr>
+              <a:t>Legal History (Q59-68)</a:t>
+            </a:r>
+          </a:p>
+        </p:txBody>
+      </p:sp>
+      <p:sp>
+        <p:nvSpPr>
+          <p:cNvPr id="0" name="TB"/>
+          <p:cNvSpPr txBox="1"/>
+          <p:nvPr/>
+        </p:nvSpPr>
+        <p:spPr>
+          <a:xfrm>
+            <a:off x="5943600" y="2212848"/>
+            <a:ext cx="2286000" cy="429768"/>
+          </a:xfrm>
+          <a:prstGeom prst="rect">
+            <a:avLst/>
+          </a:prstGeom>
+          <a:noFill/>
+        </p:spPr>
+        <p:txBody>
+          <a:bodyPr wrap="square" rtlCol="0"/>
+          <a:lstStyle/>
+          <a:p>
+            <a:pPr algn="ctr"/>
+            <a:r>
+              <a:rPr lang="en-US" sz="1200" b="1" dirty="0">
+                <a:solidFill>
+                  <a:srgbClr val="F59E0B"/>
+                </a:solidFill>
+                <a:latin typeface="Calibri"/>
+              </a:rPr>
+              <a:t>Moderate</a:t>
+            </a:r>
+          </a:p>
+        </p:txBody>
+      </p:sp>
+      <p:sp>
+        <p:nvSpPr>
+          <p:cNvPr id="0" name="TB"/>
+          <p:cNvSpPr txBox="1"/>
+          <p:nvPr/>
+        </p:nvSpPr>
+        <p:spPr>
+          <a:xfrm>
+            <a:off x="8686800" y="2212848"/>
+            <a:ext cx="2286000" cy="429768"/>
+          </a:xfrm>
+          <a:prstGeom prst="rect">
+            <a:avLst/>
+          </a:prstGeom>
+          <a:noFill/>
+        </p:spPr>
+        <p:txBody>
+          <a:bodyPr wrap="square" rtlCol="0"/>
+          <a:lstStyle/>
+          <a:p>
+            <a:pPr algn="ctr"/>
+            <a:r>
+              <a:rPr lang="en-US" sz="1200" dirty="0">
+                <a:solidFill>
+                  <a:srgbClr val="C7CFDB"/>
+                </a:solidFill>
+                <a:latin typeface="Calibri"/>
+              </a:rPr>
+              <a:t>~15</a:t>
+            </a:r>
+          </a:p>
+        </p:txBody>
+      </p:sp>
+      <p:sp>
+        <p:nvSpPr>
+          <p:cNvPr id="0" name="D2"/>
+          <p:cNvSpPr/>
+          <p:nvPr/>
+        </p:nvSpPr>
+        <p:spPr>
+          <a:xfrm>
+            <a:off x="640080" y="2734056"/>
+            <a:ext cx="10698480" cy="521207"/>
+          </a:xfrm>
+          <a:prstGeom prst="roundRect">
+            <a:avLst>
+              <a:gd name="adj" fmla="val 5000"/>
+            </a:avLst>
+          </a:prstGeom>
+          <a:solidFill>
+            <a:srgbClr val="16233A"/>
+          </a:solidFill>
+          <a:ln>
+            <a:noFill/>
+          </a:ln>
+        </p:spPr>
+        <p:txBody>
+          <a:bodyPr/>
+          <a:lstStyle/>
+          <a:p>
+            <a:endParaRPr lang="en-US"/>
+          </a:p>
+        </p:txBody>
+      </p:sp>
+      <p:sp>
+        <p:nvSpPr>
+          <p:cNvPr id="0" name="TB"/>
+          <p:cNvSpPr txBox="1"/>
+          <p:nvPr/>
+        </p:nvSpPr>
+        <p:spPr>
+          <a:xfrm>
+            <a:off x="822960" y="2779776"/>
+            <a:ext cx="4846320" cy="429768"/>
+          </a:xfrm>
+          <a:prstGeom prst="rect">
+            <a:avLst/>
+          </a:prstGeom>
+          <a:noFill/>
+        </p:spPr>
+        <p:txBody>
+          <a:bodyPr wrap="square" rtlCol="0"/>
+          <a:lstStyle/>
+          <a:p>
+            <a:pPr algn="l"/>
+            <a:r>
+              <a:rPr lang="en-US" sz="1200" dirty="0">
+                <a:solidFill>
+                  <a:srgbClr val="FFFFFF"/>
+                </a:solidFill>
+                <a:latin typeface="Calibri"/>
+              </a:rPr>
+              <a:t>Indian Polity (Q110-117)</a:t>
+            </a:r>
+          </a:p>
+        </p:txBody>
+      </p:sp>
+      <p:sp>
+        <p:nvSpPr>
+          <p:cNvPr id="0" name="TB"/>
+          <p:cNvSpPr txBox="1"/>
+          <p:nvPr/>
+        </p:nvSpPr>
+        <p:spPr>
+          <a:xfrm>
+            <a:off x="5943600" y="2779776"/>
+            <a:ext cx="2286000" cy="429768"/>
+          </a:xfrm>
+          <a:prstGeom prst="rect">
+            <a:avLst/>
+          </a:prstGeom>
+          <a:noFill/>
+        </p:spPr>
+        <p:txBody>
+          <a:bodyPr wrap="square" rtlCol="0"/>
+          <a:lstStyle/>
+          <a:p>
+            <a:pPr algn="ctr"/>
+            <a:r>
+              <a:rPr lang="en-US" sz="1200" b="1" dirty="0">
+                <a:solidFill>
+                  <a:srgbClr val="3F7D58"/>
+                </a:solidFill>
+                <a:latin typeface="Calibri"/>
+              </a:rPr>
+              <a:t>Easy-Moderate</a:t>
+            </a:r>
+          </a:p>
+        </p:txBody>
+      </p:sp>
+      <p:sp>
+        <p:nvSpPr>
+          <p:cNvPr id="0" name="TB"/>
+          <p:cNvSpPr txBox="1"/>
+          <p:nvPr/>
+        </p:nvSpPr>
+        <p:spPr>
+          <a:xfrm>
+            <a:off x="8686800" y="2779776"/>
+            <a:ext cx="2286000" cy="429768"/>
+          </a:xfrm>
+          <a:prstGeom prst="rect">
+            <a:avLst/>
+          </a:prstGeom>
+          <a:noFill/>
+        </p:spPr>
+        <p:txBody>
+          <a:bodyPr wrap="square" rtlCol="0"/>
+          <a:lstStyle/>
+          <a:p>
+            <a:pPr algn="ctr"/>
+            <a:r>
+              <a:rPr lang="en-US" sz="1200" dirty="0">
+                <a:solidFill>
+                  <a:srgbClr val="C7CFDB"/>
+                </a:solidFill>
+                <a:latin typeface="Calibri"/>
+              </a:rPr>
+              <a:t>~15</a:t>
+            </a:r>
+          </a:p>
+        </p:txBody>
+      </p:sp>
+      <p:sp>
+        <p:nvSpPr>
+          <p:cNvPr id="0" name="D3"/>
+          <p:cNvSpPr/>
+          <p:nvPr/>
+        </p:nvSpPr>
+        <p:spPr>
+          <a:xfrm>
+            <a:off x="640080" y="3300984"/>
+            <a:ext cx="10698480" cy="521207"/>
+          </a:xfrm>
+          <a:prstGeom prst="roundRect">
+            <a:avLst>
+              <a:gd name="adj" fmla="val 5000"/>
+            </a:avLst>
+          </a:prstGeom>
+          <a:solidFill>
+            <a:srgbClr val="2E4057"/>
+          </a:solidFill>
+          <a:ln>
+            <a:noFill/>
+          </a:ln>
+        </p:spPr>
+        <p:txBody>
+          <a:bodyPr/>
+          <a:lstStyle/>
+          <a:p>
+            <a:endParaRPr lang="en-US"/>
+          </a:p>
+        </p:txBody>
+      </p:sp>
+      <p:sp>
+        <p:nvSpPr>
+          <p:cNvPr id="0" name="TB"/>
+          <p:cNvSpPr txBox="1"/>
+          <p:nvPr/>
+        </p:nvSpPr>
+        <p:spPr>
+          <a:xfrm>
+            <a:off x="822960" y="3346704"/>
+            <a:ext cx="4846320" cy="429768"/>
+          </a:xfrm>
+          <a:prstGeom prst="rect">
+            <a:avLst/>
+          </a:prstGeom>
+          <a:noFill/>
+        </p:spPr>
+        <p:txBody>
+          <a:bodyPr wrap="square" rtlCol="0"/>
+          <a:lstStyle/>
+          <a:p>
+            <a:pPr algn="l"/>
+            <a:r>
+              <a:rPr lang="en-US" sz="1200" dirty="0">
+                <a:solidFill>
+                  <a:srgbClr val="FFFFFF"/>
+                </a:solidFill>
+                <a:latin typeface="Calibri"/>
+              </a:rPr>
+              <a:t>UK History &amp; Culture (Q72-96)</a:t>
+            </a:r>
+          </a:p>
+        </p:txBody>
+      </p:sp>
+      <p:sp>
+        <p:nvSpPr>
+          <p:cNvPr id="0" name="TB"/>
+          <p:cNvSpPr txBox="1"/>
+          <p:nvPr/>
+        </p:nvSpPr>
+        <p:spPr>
+          <a:xfrm>
+            <a:off x="5943600" y="3346704"/>
+            <a:ext cx="2286000" cy="429768"/>
+          </a:xfrm>
+          <a:prstGeom prst="rect">
+            <a:avLst/>
+          </a:prstGeom>
+          <a:noFill/>
+        </p:spPr>
+        <p:txBody>
+          <a:bodyPr wrap="square" rtlCol="0"/>
+          <a:lstStyle/>
+          <a:p>
+            <a:pPr algn="ctr"/>
+            <a:r>
+              <a:rPr lang="en-US" sz="1200" b="1" dirty="0">
+                <a:solidFill>
+                  <a:srgbClr val="DC3545"/>
+                </a:solidFill>
+                <a:latin typeface="Calibri"/>
+              </a:rPr>
+              <a:t>Tough</a:t>
+            </a:r>
+          </a:p>
+        </p:txBody>
+      </p:sp>
+      <p:sp>
+        <p:nvSpPr>
+          <p:cNvPr id="0" name="TB"/>
+          <p:cNvSpPr txBox="1"/>
+          <p:nvPr/>
+        </p:nvSpPr>
+        <p:spPr>
+          <a:xfrm>
+            <a:off x="8686800" y="3346704"/>
+            <a:ext cx="2286000" cy="429768"/>
+          </a:xfrm>
+          <a:prstGeom prst="rect">
+            <a:avLst/>
+          </a:prstGeom>
+          <a:noFill/>
+        </p:spPr>
+        <p:txBody>
+          <a:bodyPr wrap="square" rtlCol="0"/>
+          <a:lstStyle/>
+          <a:p>
+            <a:pPr algn="ctr"/>
+            <a:r>
+              <a:rPr lang="en-US" sz="1200" dirty="0">
+                <a:solidFill>
+                  <a:srgbClr val="C7CFDB"/>
+                </a:solidFill>
+                <a:latin typeface="Calibri"/>
+              </a:rPr>
+              <a:t>~40</a:t>
+            </a:r>
+          </a:p>
+        </p:txBody>
+      </p:sp>
+      <p:sp>
+        <p:nvSpPr>
+          <p:cNvPr id="0" name="D4"/>
+          <p:cNvSpPr/>
+          <p:nvPr/>
+        </p:nvSpPr>
+        <p:spPr>
+          <a:xfrm>
+            <a:off x="640080" y="3867912"/>
+            <a:ext cx="10698480" cy="521207"/>
+          </a:xfrm>
+          <a:prstGeom prst="roundRect">
+            <a:avLst>
+              <a:gd name="adj" fmla="val 5000"/>
+            </a:avLst>
+          </a:prstGeom>
+          <a:solidFill>
+            <a:srgbClr val="16233A"/>
+          </a:solidFill>
+          <a:ln>
+            <a:noFill/>
+          </a:ln>
+        </p:spPr>
+        <p:txBody>
+          <a:bodyPr/>
+          <a:lstStyle/>
+          <a:p>
+            <a:endParaRPr lang="en-US"/>
+          </a:p>
+        </p:txBody>
+      </p:sp>
+      <p:sp>
+        <p:nvSpPr>
+          <p:cNvPr id="0" name="TB"/>
+          <p:cNvSpPr txBox="1"/>
+          <p:nvPr/>
+        </p:nvSpPr>
+        <p:spPr>
+          <a:xfrm>
+            <a:off x="822960" y="3913632"/>
+            <a:ext cx="4846320" cy="429768"/>
+          </a:xfrm>
+          <a:prstGeom prst="rect">
+            <a:avLst/>
+          </a:prstGeom>
+          <a:noFill/>
+        </p:spPr>
+        <p:txBody>
+          <a:bodyPr wrap="square" rtlCol="0"/>
+          <a:lstStyle/>
+          <a:p>
+            <a:pPr algn="l"/>
+            <a:r>
+              <a:rPr lang="en-US" sz="1200" dirty="0">
+                <a:solidFill>
+                  <a:srgbClr val="FFFFFF"/>
+                </a:solidFill>
+                <a:latin typeface="Calibri"/>
+              </a:rPr>
+              <a:t>UK Current &amp; Schemes (Q97-109)</a:t>
+            </a:r>
+          </a:p>
+        </p:txBody>
+      </p:sp>
+      <p:sp>
+        <p:nvSpPr>
+          <p:cNvPr id="0" name="TB"/>
+          <p:cNvSpPr txBox="1"/>
+          <p:nvPr/>
+        </p:nvSpPr>
+        <p:spPr>
+          <a:xfrm>
+            <a:off x="5943600" y="3913632"/>
+            <a:ext cx="2286000" cy="429768"/>
+          </a:xfrm>
+          <a:prstGeom prst="rect">
+            <a:avLst/>
+          </a:prstGeom>
+          <a:noFill/>
+        </p:spPr>
+        <p:txBody>
+          <a:bodyPr wrap="square" rtlCol="0"/>
+          <a:lstStyle/>
+          <a:p>
+            <a:pPr algn="ctr"/>
+            <a:r>
+              <a:rPr lang="en-US" sz="1200" b="1" dirty="0">
+                <a:solidFill>
+                  <a:srgbClr val="F59E0B"/>
+                </a:solidFill>
+                <a:latin typeface="Calibri"/>
+              </a:rPr>
+              <a:t>Moderate</a:t>
+            </a:r>
+          </a:p>
+        </p:txBody>
+      </p:sp>
+      <p:sp>
+        <p:nvSpPr>
+          <p:cNvPr id="0" name="TB"/>
+          <p:cNvSpPr txBox="1"/>
+          <p:nvPr/>
+        </p:nvSpPr>
+        <p:spPr>
+          <a:xfrm>
+            <a:off x="8686800" y="3913632"/>
+            <a:ext cx="2286000" cy="429768"/>
+          </a:xfrm>
+          <a:prstGeom prst="rect">
+            <a:avLst/>
+          </a:prstGeom>
+          <a:noFill/>
+        </p:spPr>
+        <p:txBody>
+          <a:bodyPr wrap="square" rtlCol="0"/>
+          <a:lstStyle/>
+          <a:p>
+            <a:pPr algn="ctr"/>
+            <a:r>
+              <a:rPr lang="en-US" sz="1200" dirty="0">
+                <a:solidFill>
+                  <a:srgbClr val="C7CFDB"/>
+                </a:solidFill>
+                <a:latin typeface="Calibri"/>
+              </a:rPr>
+              <a:t>~15</a:t>
+            </a:r>
+          </a:p>
+        </p:txBody>
+      </p:sp>
+      <p:sp>
+        <p:nvSpPr>
+          <p:cNvPr id="0" name="D5"/>
+          <p:cNvSpPr/>
+          <p:nvPr/>
+        </p:nvSpPr>
+        <p:spPr>
+          <a:xfrm>
+            <a:off x="640080" y="4434840"/>
+            <a:ext cx="10698480" cy="521207"/>
+          </a:xfrm>
+          <a:prstGeom prst="roundRect">
+            <a:avLst>
+              <a:gd name="adj" fmla="val 5000"/>
+            </a:avLst>
+          </a:prstGeom>
+          <a:solidFill>
+            <a:srgbClr val="2E4057"/>
+          </a:solidFill>
+          <a:ln>
+            <a:noFill/>
+          </a:ln>
+        </p:spPr>
+        <p:txBody>
+          <a:bodyPr/>
+          <a:lstStyle/>
+          <a:p>
+            <a:endParaRPr lang="en-US"/>
+          </a:p>
+        </p:txBody>
+      </p:sp>
+      <p:sp>
+        <p:nvSpPr>
+          <p:cNvPr id="0" name="TB"/>
+          <p:cNvSpPr txBox="1"/>
+          <p:nvPr/>
+        </p:nvSpPr>
+        <p:spPr>
+          <a:xfrm>
+            <a:off x="822960" y="4480560"/>
+            <a:ext cx="4846320" cy="429768"/>
+          </a:xfrm>
+          <a:prstGeom prst="rect">
+            <a:avLst/>
+          </a:prstGeom>
+          <a:noFill/>
+        </p:spPr>
+        <p:txBody>
+          <a:bodyPr wrap="square" rtlCol="0"/>
+          <a:lstStyle/>
+          <a:p>
+            <a:pPr algn="l"/>
+            <a:r>
+              <a:rPr lang="en-US" sz="1200" dirty="0">
+                <a:solidFill>
+                  <a:srgbClr val="FFFFFF"/>
+                </a:solidFill>
+                <a:latin typeface="Calibri"/>
+              </a:rPr>
+              <a:t>National Current Affairs (Q177-195)</a:t>
+            </a:r>
+          </a:p>
+        </p:txBody>
+      </p:sp>
+      <p:sp>
+        <p:nvSpPr>
+          <p:cNvPr id="0" name="TB"/>
+          <p:cNvSpPr txBox="1"/>
+          <p:nvPr/>
+        </p:nvSpPr>
+        <p:spPr>
+          <a:xfrm>
+            <a:off x="5943600" y="4480560"/>
+            <a:ext cx="2286000" cy="429768"/>
+          </a:xfrm>
+          <a:prstGeom prst="rect">
+            <a:avLst/>
+          </a:prstGeom>
+          <a:noFill/>
+        </p:spPr>
+        <p:txBody>
+          <a:bodyPr wrap="square" rtlCol="0"/>
+          <a:lstStyle/>
+          <a:p>
+            <a:pPr algn="ctr"/>
+            <a:r>
+              <a:rPr lang="en-US" sz="1200" b="1" dirty="0">
+                <a:solidFill>
+                  <a:srgbClr val="3F7D58"/>
+                </a:solidFill>
+                <a:latin typeface="Calibri"/>
+              </a:rPr>
+              <a:t>Easy-Moderate</a:t>
+            </a:r>
+          </a:p>
+        </p:txBody>
+      </p:sp>
+      <p:sp>
+        <p:nvSpPr>
+          <p:cNvPr id="0" name="TB"/>
+          <p:cNvSpPr txBox="1"/>
+          <p:nvPr/>
+        </p:nvSpPr>
+        <p:spPr>
+          <a:xfrm>
+            <a:off x="8686800" y="4480560"/>
+            <a:ext cx="2286000" cy="429768"/>
+          </a:xfrm>
+          <a:prstGeom prst="rect">
+            <a:avLst/>
+          </a:prstGeom>
+          <a:noFill/>
+        </p:spPr>
+        <p:txBody>
+          <a:bodyPr wrap="square" rtlCol="0"/>
+          <a:lstStyle/>
+          <a:p>
+            <a:pPr algn="ctr"/>
+            <a:r>
+              <a:rPr lang="en-US" sz="1200" dirty="0">
+                <a:solidFill>
+                  <a:srgbClr val="C7CFDB"/>
+                </a:solidFill>
+                <a:latin typeface="Calibri"/>
+              </a:rPr>
+              <a:t>~20</a:t>
+            </a:r>
+          </a:p>
+        </p:txBody>
+      </p:sp>
+      <p:sp>
+        <p:nvSpPr>
+          <p:cNvPr id="0" name="D6"/>
+          <p:cNvSpPr/>
+          <p:nvPr/>
+        </p:nvSpPr>
+        <p:spPr>
+          <a:xfrm>
+            <a:off x="640080" y="5001768"/>
+            <a:ext cx="10698480" cy="521207"/>
+          </a:xfrm>
+          <a:prstGeom prst="roundRect">
+            <a:avLst>
+              <a:gd name="adj" fmla="val 5000"/>
+            </a:avLst>
+          </a:prstGeom>
+          <a:solidFill>
+            <a:srgbClr val="16233A"/>
+          </a:solidFill>
+          <a:ln>
+            <a:noFill/>
+          </a:ln>
+        </p:spPr>
+        <p:txBody>
+          <a:bodyPr/>
+          <a:lstStyle/>
+          <a:p>
+            <a:endParaRPr lang="en-US"/>
+          </a:p>
+        </p:txBody>
+      </p:sp>
+      <p:sp>
+        <p:nvSpPr>
+          <p:cNvPr id="0" name="TB"/>
+          <p:cNvSpPr txBox="1"/>
+          <p:nvPr/>
+        </p:nvSpPr>
+        <p:spPr>
+          <a:xfrm>
+            <a:off x="822960" y="5047488"/>
+            <a:ext cx="4846320" cy="429768"/>
+          </a:xfrm>
+          <a:prstGeom prst="rect">
+            <a:avLst/>
+          </a:prstGeom>
+          <a:noFill/>
+        </p:spPr>
+        <p:txBody>
+          <a:bodyPr wrap="square" rtlCol="0"/>
+          <a:lstStyle/>
+          <a:p>
+            <a:pPr algn="l"/>
+            <a:r>
+              <a:rPr lang="en-US" sz="1200" dirty="0">
+                <a:solidFill>
+                  <a:srgbClr val="FFFFFF"/>
+                </a:solidFill>
+                <a:latin typeface="Calibri"/>
+              </a:rPr>
+              <a:t>Science &amp; Computer</a:t>
+            </a:r>
+          </a:p>
+        </p:txBody>
+      </p:sp>
+      <p:sp>
+        <p:nvSpPr>
+          <p:cNvPr id="0" name="TB"/>
+          <p:cNvSpPr txBox="1"/>
+          <p:nvPr/>
+        </p:nvSpPr>
+        <p:spPr>
+          <a:xfrm>
+            <a:off x="5943600" y="5047488"/>
+            <a:ext cx="2286000" cy="429768"/>
+          </a:xfrm>
+          <a:prstGeom prst="rect">
+            <a:avLst/>
+          </a:prstGeom>
+          <a:noFill/>
+        </p:spPr>
+        <p:txBody>
+          <a:bodyPr wrap="square" rtlCol="0"/>
+          <a:lstStyle/>
+          <a:p>
+            <a:pPr algn="ctr"/>
+            <a:r>
+              <a:rPr lang="en-US" sz="1200" b="1" dirty="0">
+                <a:solidFill>
+                  <a:srgbClr val="F59E0B"/>
+                </a:solidFill>
+                <a:latin typeface="Calibri"/>
+              </a:rPr>
+              <a:t>Moderate</a:t>
+            </a:r>
+          </a:p>
+        </p:txBody>
+      </p:sp>
+      <p:sp>
+        <p:nvSpPr>
+          <p:cNvPr id="0" name="TB"/>
+          <p:cNvSpPr txBox="1"/>
+          <p:nvPr/>
+        </p:nvSpPr>
+        <p:spPr>
+          <a:xfrm>
+            <a:off x="8686800" y="5047488"/>
+            <a:ext cx="2286000" cy="429768"/>
+          </a:xfrm>
+          <a:prstGeom prst="rect">
+            <a:avLst/>
+          </a:prstGeom>
+          <a:noFill/>
+        </p:spPr>
+        <p:txBody>
+          <a:bodyPr wrap="square" rtlCol="0"/>
+          <a:lstStyle/>
+          <a:p>
+            <a:pPr algn="ctr"/>
+            <a:r>
+              <a:rPr lang="en-US" sz="1200" dirty="0">
+                <a:solidFill>
+                  <a:srgbClr val="C7CFDB"/>
+                </a:solidFill>
+                <a:latin typeface="Calibri"/>
+              </a:rPr>
+              <a:t>~15</a:t>
+            </a:r>
+          </a:p>
+        </p:txBody>
+      </p:sp>
+      <p:sp>
+        <p:nvSpPr>
+          <p:cNvPr id="0" name="D7"/>
+          <p:cNvSpPr/>
+          <p:nvPr/>
+        </p:nvSpPr>
+        <p:spPr>
+          <a:xfrm>
+            <a:off x="640080" y="5568696"/>
+            <a:ext cx="10698480" cy="521207"/>
+          </a:xfrm>
+          <a:prstGeom prst="roundRect">
+            <a:avLst>
+              <a:gd name="adj" fmla="val 5000"/>
+            </a:avLst>
+          </a:prstGeom>
+          <a:solidFill>
+            <a:srgbClr val="2E4057"/>
+          </a:solidFill>
+          <a:ln>
+            <a:noFill/>
+          </a:ln>
+        </p:spPr>
+        <p:txBody>
+          <a:bodyPr/>
+          <a:lstStyle/>
+          <a:p>
+            <a:endParaRPr lang="en-US"/>
+          </a:p>
+        </p:txBody>
+      </p:sp>
+      <p:sp>
+        <p:nvSpPr>
+          <p:cNvPr id="0" name="TB"/>
+          <p:cNvSpPr txBox="1"/>
+          <p:nvPr/>
+        </p:nvSpPr>
+        <p:spPr>
+          <a:xfrm>
+            <a:off x="822960" y="5614416"/>
+            <a:ext cx="4846320" cy="429768"/>
+          </a:xfrm>
+          <a:prstGeom prst="rect">
+            <a:avLst/>
+          </a:prstGeom>
+          <a:noFill/>
+        </p:spPr>
+        <p:txBody>
+          <a:bodyPr wrap="square" rtlCol="0"/>
+          <a:lstStyle/>
+          <a:p>
+            <a:pPr algn="l"/>
+            <a:r>
+              <a:rPr lang="en-US" sz="1200" dirty="0">
+                <a:solidFill>
+                  <a:srgbClr val="FFFFFF"/>
+                </a:solidFill>
+                <a:latin typeface="Calibri"/>
+              </a:rPr>
+              <a:t>Maths &amp; Reasoning</a:t>
+            </a:r>
+          </a:p>
+        </p:txBody>
+      </p:sp>
+      <p:sp>
+        <p:nvSpPr>
+          <p:cNvPr id="0" name="TB"/>
+          <p:cNvSpPr txBox="1"/>
+          <p:nvPr/>
+        </p:nvSpPr>
+        <p:spPr>
+          <a:xfrm>
+            <a:off x="5943600" y="5614416"/>
+            <a:ext cx="2286000" cy="429768"/>
+          </a:xfrm>
+          <a:prstGeom prst="rect">
+            <a:avLst/>
+          </a:prstGeom>
+          <a:noFill/>
+        </p:spPr>
+        <p:txBody>
+          <a:bodyPr wrap="square" rtlCol="0"/>
+          <a:lstStyle/>
+          <a:p>
+            <a:pPr algn="ctr"/>
+            <a:r>
+              <a:rPr lang="en-US" sz="1200" b="1" dirty="0">
+                <a:solidFill>
+                  <a:srgbClr val="F59E0B"/>
+                </a:solidFill>
+                <a:latin typeface="Calibri"/>
+              </a:rPr>
+              <a:t>Moderate</a:t>
+            </a:r>
+          </a:p>
+        </p:txBody>
+      </p:sp>
+      <p:sp>
+        <p:nvSpPr>
+          <p:cNvPr id="0" name="TB"/>
+          <p:cNvSpPr txBox="1"/>
+          <p:nvPr/>
+        </p:nvSpPr>
+        <p:spPr>
+          <a:xfrm>
+            <a:off x="8686800" y="5614416"/>
+            <a:ext cx="2286000" cy="429768"/>
+          </a:xfrm>
+          <a:prstGeom prst="rect">
+            <a:avLst/>
+          </a:prstGeom>
+          <a:noFill/>
+        </p:spPr>
+        <p:txBody>
+          <a:bodyPr wrap="square" rtlCol="0"/>
+          <a:lstStyle/>
+          <a:p>
+            <a:pPr algn="ctr"/>
+            <a:r>
+              <a:rPr lang="en-US" sz="1200" dirty="0">
+                <a:solidFill>
+                  <a:srgbClr val="C7CFDB"/>
+                </a:solidFill>
+                <a:latin typeface="Calibri"/>
+              </a:rPr>
+              <a:t>~20</a:t>
+            </a:r>
+          </a:p>
+        </p:txBody>
+      </p:sp>
+      <p:sp>
+        <p:nvSpPr>
+          <p:cNvPr id="0" name="OV"/>
+          <p:cNvSpPr/>
+          <p:nvPr/>
+        </p:nvSpPr>
+        <p:spPr>
+          <a:xfrm>
+            <a:off x="640080" y="6035040"/>
+            <a:ext cx="10698480" cy="548640"/>
+          </a:xfrm>
+          <a:prstGeom prst="roundRect">
+            <a:avLst>
+              <a:gd name="adj" fmla="val 5000"/>
+            </a:avLst>
+          </a:prstGeom>
+          <a:solidFill>
+            <a:srgbClr val="E0A458"/>
+          </a:solidFill>
+          <a:ln>
+            <a:noFill/>
+          </a:ln>
+        </p:spPr>
+        <p:txBody>
+          <a:bodyPr/>
+          <a:lstStyle/>
+          <a:p>
+            <a:endParaRPr lang="en-US"/>
+          </a:p>
+        </p:txBody>
+      </p:sp>
+      <p:sp>
+        <p:nvSpPr>
+          <p:cNvPr id="0" name="TB"/>
+          <p:cNvSpPr txBox="1"/>
+          <p:nvPr/>
+        </p:nvSpPr>
+        <p:spPr>
+          <a:xfrm>
+            <a:off x="914400" y="6080760"/>
+            <a:ext cx="10241280" cy="457200"/>
+          </a:xfrm>
+          <a:prstGeom prst="rect">
+            <a:avLst/>
+          </a:prstGeom>
+          <a:noFill/>
+        </p:spPr>
+        <p:txBody>
+          <a:bodyPr wrap="square" rtlCol="0"/>
+          <a:lstStyle/>
+          <a:p>
+            <a:pPr algn="ctr"/>
+            <a:r>
+              <a:rPr lang="en-US" sz="1400" b="1" dirty="0">
+                <a:solidFill>
+                  <a:srgbClr val="16233A"/>
+                </a:solidFill>
+                <a:latin typeface="Calibri"/>
+              </a:rPr>
+              <a:t>Overall Paper Level: MODERATE (with TOUGH Legal + UK History sections)</a:t>
+            </a:r>
+          </a:p>
+        </p:txBody>
+      </p:sp>
     </p:spTree>
   </p:cSld>
-  <p:clrMapOvr><a:masterClrMapping/></p:clrMapOvr>
+  <p:clrMapOvr>
+    <a:masterClrMapping/>
+  </p:clrMapOvr>
 </p:sld>
 </file>
 

</xml_diff>